<commit_message>
feat: embed live app screenshots (Topology, Reachability Matrix, AI Optimizer, P2P Trading in INR) into presentation deck
</commit_message>
<xml_diff>
--- a/Solar_Share_Grid_Presentation.pptx
+++ b/Solar_Share_Grid_Presentation.pptx
@@ -8,6 +8,8 @@
     <p:sldId id="256" r:id="rId2"/>
     <p:sldId id="257" r:id="rId3"/>
     <p:sldId id="258" r:id="rId4"/>
+    <p:sldId id="259" r:id="rId5"/>
+    <p:sldId id="260" r:id="rId6"/>
   </p:sldIdLst>
   <p:sldSz cx="12192000" cy="6858000"/>
   <p:notesSz cx="6858000" cy="9144000"/>
@@ -131,7 +133,7 @@
           <p:cNvPr id="2" name="Title 1">
             <a:extLst>
               <a:ext uri="{FF2B5EF4-FFF2-40B4-BE49-F238E27FC236}">
-                <a16:creationId xmlns:a16="http://schemas.microsoft.com/office/drawing/2014/main" id="{4B0C7BAE-8891-0360-FB58-A47409D542C0}"/>
+                <a16:creationId xmlns:a16="http://schemas.microsoft.com/office/drawing/2014/main" id="{5B8C409A-C710-FAF6-4E7D-CA0A7764175D}"/>
               </a:ext>
             </a:extLst>
           </p:cNvPr>
@@ -169,7 +171,7 @@
           <p:cNvPr id="3" name="Subtitle 2">
             <a:extLst>
               <a:ext uri="{FF2B5EF4-FFF2-40B4-BE49-F238E27FC236}">
-                <a16:creationId xmlns:a16="http://schemas.microsoft.com/office/drawing/2014/main" id="{55882EE3-020A-4D09-B77E-88283DFE5170}"/>
+                <a16:creationId xmlns:a16="http://schemas.microsoft.com/office/drawing/2014/main" id="{1DE552A8-7F9E-1493-B025-4CF527417C8C}"/>
               </a:ext>
             </a:extLst>
           </p:cNvPr>
@@ -240,7 +242,7 @@
           <p:cNvPr id="4" name="Date Placeholder 3">
             <a:extLst>
               <a:ext uri="{FF2B5EF4-FFF2-40B4-BE49-F238E27FC236}">
-                <a16:creationId xmlns:a16="http://schemas.microsoft.com/office/drawing/2014/main" id="{DF8C4E82-FD3A-59E8-5E5C-2EDF388E37CA}"/>
+                <a16:creationId xmlns:a16="http://schemas.microsoft.com/office/drawing/2014/main" id="{40AB0347-5BE5-F83B-822B-AEBF7DA08129}"/>
               </a:ext>
             </a:extLst>
           </p:cNvPr>
@@ -256,9 +258,9 @@
           <a:bodyPr/>
           <a:lstStyle/>
           <a:p>
-            <a:fld id="{7F840261-00B1-4F86-8DD0-5B727C2002AD}" type="datetimeFigureOut">
+            <a:fld id="{E54C691A-9324-4AF1-A836-5C73D2BDC322}" type="datetimeFigureOut">
               <a:rPr lang="en-IN" smtClean="0"/>
-              <a:t>05-10-2026</a:t>
+              <a:t>19-10-2026</a:t>
             </a:fld>
             <a:endParaRPr lang="en-IN"/>
           </a:p>
@@ -269,7 +271,7 @@
           <p:cNvPr id="5" name="Footer Placeholder 4">
             <a:extLst>
               <a:ext uri="{FF2B5EF4-FFF2-40B4-BE49-F238E27FC236}">
-                <a16:creationId xmlns:a16="http://schemas.microsoft.com/office/drawing/2014/main" id="{9E9647E6-7604-2770-B7F7-0924EB62BB5D}"/>
+                <a16:creationId xmlns:a16="http://schemas.microsoft.com/office/drawing/2014/main" id="{447B992D-F038-4BC3-CE6E-21A9303CE219}"/>
               </a:ext>
             </a:extLst>
           </p:cNvPr>
@@ -294,7 +296,7 @@
           <p:cNvPr id="6" name="Slide Number Placeholder 5">
             <a:extLst>
               <a:ext uri="{FF2B5EF4-FFF2-40B4-BE49-F238E27FC236}">
-                <a16:creationId xmlns:a16="http://schemas.microsoft.com/office/drawing/2014/main" id="{A113EB49-F27B-BDD9-7B23-BA03A956FD9E}"/>
+                <a16:creationId xmlns:a16="http://schemas.microsoft.com/office/drawing/2014/main" id="{4F823EC3-CA1C-6DC5-484A-73CCE3FBB976}"/>
               </a:ext>
             </a:extLst>
           </p:cNvPr>
@@ -310,7 +312,7 @@
           <a:bodyPr/>
           <a:lstStyle/>
           <a:p>
-            <a:fld id="{1D7225A6-8455-47B9-AB87-26931A7E0C65}" type="slidenum">
+            <a:fld id="{13B1E2B3-EF09-4EBF-B449-23BBEF5D6C12}" type="slidenum">
               <a:rPr lang="en-IN" smtClean="0"/>
               <a:t>‹#›</a:t>
             </a:fld>
@@ -321,7 +323,7 @@
     </p:spTree>
     <p:extLst>
       <p:ext uri="{BB962C8B-B14F-4D97-AF65-F5344CB8AC3E}">
-        <p14:creationId xmlns:p14="http://schemas.microsoft.com/office/powerpoint/2010/main" val="1025613954"/>
+        <p14:creationId xmlns:p14="http://schemas.microsoft.com/office/powerpoint/2010/main" val="3769692689"/>
       </p:ext>
     </p:extLst>
   </p:cSld>
@@ -353,7 +355,7 @@
           <p:cNvPr id="2" name="Title 1">
             <a:extLst>
               <a:ext uri="{FF2B5EF4-FFF2-40B4-BE49-F238E27FC236}">
-                <a16:creationId xmlns:a16="http://schemas.microsoft.com/office/drawing/2014/main" id="{5EAC5986-C189-7C93-99C7-B38E5C64D62A}"/>
+                <a16:creationId xmlns:a16="http://schemas.microsoft.com/office/drawing/2014/main" id="{A52BB2F9-057C-D4C5-529C-3342DD3E55AC}"/>
               </a:ext>
             </a:extLst>
           </p:cNvPr>
@@ -382,7 +384,7 @@
           <p:cNvPr id="3" name="Vertical Text Placeholder 2">
             <a:extLst>
               <a:ext uri="{FF2B5EF4-FFF2-40B4-BE49-F238E27FC236}">
-                <a16:creationId xmlns:a16="http://schemas.microsoft.com/office/drawing/2014/main" id="{81A04824-A41D-7297-4734-9FB4C26999E9}"/>
+                <a16:creationId xmlns:a16="http://schemas.microsoft.com/office/drawing/2014/main" id="{3022D1D0-7851-C50A-6891-EFD6D89C527F}"/>
               </a:ext>
             </a:extLst>
           </p:cNvPr>
@@ -440,7 +442,7 @@
           <p:cNvPr id="4" name="Date Placeholder 3">
             <a:extLst>
               <a:ext uri="{FF2B5EF4-FFF2-40B4-BE49-F238E27FC236}">
-                <a16:creationId xmlns:a16="http://schemas.microsoft.com/office/drawing/2014/main" id="{13E3C4A3-63B1-69BA-A8C8-3294DFD39F59}"/>
+                <a16:creationId xmlns:a16="http://schemas.microsoft.com/office/drawing/2014/main" id="{E66B2D89-58A4-427C-BED1-2D40EFA75A36}"/>
               </a:ext>
             </a:extLst>
           </p:cNvPr>
@@ -456,9 +458,9 @@
           <a:bodyPr/>
           <a:lstStyle/>
           <a:p>
-            <a:fld id="{7F840261-00B1-4F86-8DD0-5B727C2002AD}" type="datetimeFigureOut">
+            <a:fld id="{E54C691A-9324-4AF1-A836-5C73D2BDC322}" type="datetimeFigureOut">
               <a:rPr lang="en-IN" smtClean="0"/>
-              <a:t>05-10-2026</a:t>
+              <a:t>19-10-2026</a:t>
             </a:fld>
             <a:endParaRPr lang="en-IN"/>
           </a:p>
@@ -469,7 +471,7 @@
           <p:cNvPr id="5" name="Footer Placeholder 4">
             <a:extLst>
               <a:ext uri="{FF2B5EF4-FFF2-40B4-BE49-F238E27FC236}">
-                <a16:creationId xmlns:a16="http://schemas.microsoft.com/office/drawing/2014/main" id="{8260CC20-841F-ED9E-DF13-7D05B3619310}"/>
+                <a16:creationId xmlns:a16="http://schemas.microsoft.com/office/drawing/2014/main" id="{21BE1BD1-4B82-552E-487A-7B9A0059C065}"/>
               </a:ext>
             </a:extLst>
           </p:cNvPr>
@@ -494,7 +496,7 @@
           <p:cNvPr id="6" name="Slide Number Placeholder 5">
             <a:extLst>
               <a:ext uri="{FF2B5EF4-FFF2-40B4-BE49-F238E27FC236}">
-                <a16:creationId xmlns:a16="http://schemas.microsoft.com/office/drawing/2014/main" id="{378F7164-2151-BB01-640F-BCFDCB756EFF}"/>
+                <a16:creationId xmlns:a16="http://schemas.microsoft.com/office/drawing/2014/main" id="{695D1984-76C6-D583-D4E7-4E5B23EC67B6}"/>
               </a:ext>
             </a:extLst>
           </p:cNvPr>
@@ -510,7 +512,7 @@
           <a:bodyPr/>
           <a:lstStyle/>
           <a:p>
-            <a:fld id="{1D7225A6-8455-47B9-AB87-26931A7E0C65}" type="slidenum">
+            <a:fld id="{13B1E2B3-EF09-4EBF-B449-23BBEF5D6C12}" type="slidenum">
               <a:rPr lang="en-IN" smtClean="0"/>
               <a:t>‹#›</a:t>
             </a:fld>
@@ -521,7 +523,7 @@
     </p:spTree>
     <p:extLst>
       <p:ext uri="{BB962C8B-B14F-4D97-AF65-F5344CB8AC3E}">
-        <p14:creationId xmlns:p14="http://schemas.microsoft.com/office/powerpoint/2010/main" val="3934519395"/>
+        <p14:creationId xmlns:p14="http://schemas.microsoft.com/office/powerpoint/2010/main" val="2529005373"/>
       </p:ext>
     </p:extLst>
   </p:cSld>
@@ -553,7 +555,7 @@
           <p:cNvPr id="2" name="Vertical Title 1">
             <a:extLst>
               <a:ext uri="{FF2B5EF4-FFF2-40B4-BE49-F238E27FC236}">
-                <a16:creationId xmlns:a16="http://schemas.microsoft.com/office/drawing/2014/main" id="{2A07993D-C249-DEC5-F9F0-C180BC13059F}"/>
+                <a16:creationId xmlns:a16="http://schemas.microsoft.com/office/drawing/2014/main" id="{8571BA57-6BC6-4DA5-38E1-C85F1683E827}"/>
               </a:ext>
             </a:extLst>
           </p:cNvPr>
@@ -587,7 +589,7 @@
           <p:cNvPr id="3" name="Vertical Text Placeholder 2">
             <a:extLst>
               <a:ext uri="{FF2B5EF4-FFF2-40B4-BE49-F238E27FC236}">
-                <a16:creationId xmlns:a16="http://schemas.microsoft.com/office/drawing/2014/main" id="{9F4B4810-59C0-7B6B-902E-2D3FCF8F20AA}"/>
+                <a16:creationId xmlns:a16="http://schemas.microsoft.com/office/drawing/2014/main" id="{FDF38F1F-C3BC-F623-3E85-33BBD36077FF}"/>
               </a:ext>
             </a:extLst>
           </p:cNvPr>
@@ -650,7 +652,7 @@
           <p:cNvPr id="4" name="Date Placeholder 3">
             <a:extLst>
               <a:ext uri="{FF2B5EF4-FFF2-40B4-BE49-F238E27FC236}">
-                <a16:creationId xmlns:a16="http://schemas.microsoft.com/office/drawing/2014/main" id="{B35C0BE0-1A07-AA6B-FF20-7E03702F3FA0}"/>
+                <a16:creationId xmlns:a16="http://schemas.microsoft.com/office/drawing/2014/main" id="{156DE723-836F-D394-3478-97B87538C3E7}"/>
               </a:ext>
             </a:extLst>
           </p:cNvPr>
@@ -666,9 +668,9 @@
           <a:bodyPr/>
           <a:lstStyle/>
           <a:p>
-            <a:fld id="{7F840261-00B1-4F86-8DD0-5B727C2002AD}" type="datetimeFigureOut">
+            <a:fld id="{E54C691A-9324-4AF1-A836-5C73D2BDC322}" type="datetimeFigureOut">
               <a:rPr lang="en-IN" smtClean="0"/>
-              <a:t>05-10-2026</a:t>
+              <a:t>19-10-2026</a:t>
             </a:fld>
             <a:endParaRPr lang="en-IN"/>
           </a:p>
@@ -679,7 +681,7 @@
           <p:cNvPr id="5" name="Footer Placeholder 4">
             <a:extLst>
               <a:ext uri="{FF2B5EF4-FFF2-40B4-BE49-F238E27FC236}">
-                <a16:creationId xmlns:a16="http://schemas.microsoft.com/office/drawing/2014/main" id="{6A7BB068-A4AE-495F-FB06-09371E584DA3}"/>
+                <a16:creationId xmlns:a16="http://schemas.microsoft.com/office/drawing/2014/main" id="{8682B7CC-5226-8C1F-6EBF-DE132262BB26}"/>
               </a:ext>
             </a:extLst>
           </p:cNvPr>
@@ -704,7 +706,7 @@
           <p:cNvPr id="6" name="Slide Number Placeholder 5">
             <a:extLst>
               <a:ext uri="{FF2B5EF4-FFF2-40B4-BE49-F238E27FC236}">
-                <a16:creationId xmlns:a16="http://schemas.microsoft.com/office/drawing/2014/main" id="{D4AE5731-4F27-4817-7181-D40522858A96}"/>
+                <a16:creationId xmlns:a16="http://schemas.microsoft.com/office/drawing/2014/main" id="{778FBDB1-8C11-822B-7439-1062FCDF77E3}"/>
               </a:ext>
             </a:extLst>
           </p:cNvPr>
@@ -720,7 +722,7 @@
           <a:bodyPr/>
           <a:lstStyle/>
           <a:p>
-            <a:fld id="{1D7225A6-8455-47B9-AB87-26931A7E0C65}" type="slidenum">
+            <a:fld id="{13B1E2B3-EF09-4EBF-B449-23BBEF5D6C12}" type="slidenum">
               <a:rPr lang="en-IN" smtClean="0"/>
               <a:t>‹#›</a:t>
             </a:fld>
@@ -731,7 +733,7 @@
     </p:spTree>
     <p:extLst>
       <p:ext uri="{BB962C8B-B14F-4D97-AF65-F5344CB8AC3E}">
-        <p14:creationId xmlns:p14="http://schemas.microsoft.com/office/powerpoint/2010/main" val="674024667"/>
+        <p14:creationId xmlns:p14="http://schemas.microsoft.com/office/powerpoint/2010/main" val="3348405290"/>
       </p:ext>
     </p:extLst>
   </p:cSld>
@@ -763,7 +765,7 @@
           <p:cNvPr id="2" name="Title 1">
             <a:extLst>
               <a:ext uri="{FF2B5EF4-FFF2-40B4-BE49-F238E27FC236}">
-                <a16:creationId xmlns:a16="http://schemas.microsoft.com/office/drawing/2014/main" id="{4403B4F5-DD79-4B11-3B69-4D267D4000BE}"/>
+                <a16:creationId xmlns:a16="http://schemas.microsoft.com/office/drawing/2014/main" id="{6292EE1F-00F8-293C-E28E-D8B69374A694}"/>
               </a:ext>
             </a:extLst>
           </p:cNvPr>
@@ -792,7 +794,7 @@
           <p:cNvPr id="3" name="Content Placeholder 2">
             <a:extLst>
               <a:ext uri="{FF2B5EF4-FFF2-40B4-BE49-F238E27FC236}">
-                <a16:creationId xmlns:a16="http://schemas.microsoft.com/office/drawing/2014/main" id="{14FDE2F4-69E4-A2CA-35D5-D58DD5835C87}"/>
+                <a16:creationId xmlns:a16="http://schemas.microsoft.com/office/drawing/2014/main" id="{536E8727-1BA8-FC31-93B1-12A6D3D45A5D}"/>
               </a:ext>
             </a:extLst>
           </p:cNvPr>
@@ -850,7 +852,7 @@
           <p:cNvPr id="4" name="Date Placeholder 3">
             <a:extLst>
               <a:ext uri="{FF2B5EF4-FFF2-40B4-BE49-F238E27FC236}">
-                <a16:creationId xmlns:a16="http://schemas.microsoft.com/office/drawing/2014/main" id="{68484A93-02DE-140E-DB3F-A9597BB799AB}"/>
+                <a16:creationId xmlns:a16="http://schemas.microsoft.com/office/drawing/2014/main" id="{E4858321-C54E-1838-B4CE-4D19AE55EE36}"/>
               </a:ext>
             </a:extLst>
           </p:cNvPr>
@@ -866,9 +868,9 @@
           <a:bodyPr/>
           <a:lstStyle/>
           <a:p>
-            <a:fld id="{7F840261-00B1-4F86-8DD0-5B727C2002AD}" type="datetimeFigureOut">
+            <a:fld id="{E54C691A-9324-4AF1-A836-5C73D2BDC322}" type="datetimeFigureOut">
               <a:rPr lang="en-IN" smtClean="0"/>
-              <a:t>05-10-2026</a:t>
+              <a:t>19-10-2026</a:t>
             </a:fld>
             <a:endParaRPr lang="en-IN"/>
           </a:p>
@@ -879,7 +881,7 @@
           <p:cNvPr id="5" name="Footer Placeholder 4">
             <a:extLst>
               <a:ext uri="{FF2B5EF4-FFF2-40B4-BE49-F238E27FC236}">
-                <a16:creationId xmlns:a16="http://schemas.microsoft.com/office/drawing/2014/main" id="{6DF3820C-2BB9-349F-D6CB-E9DFCCDC89FA}"/>
+                <a16:creationId xmlns:a16="http://schemas.microsoft.com/office/drawing/2014/main" id="{B07D3488-B31E-B54B-4B18-E10824D84760}"/>
               </a:ext>
             </a:extLst>
           </p:cNvPr>
@@ -904,7 +906,7 @@
           <p:cNvPr id="6" name="Slide Number Placeholder 5">
             <a:extLst>
               <a:ext uri="{FF2B5EF4-FFF2-40B4-BE49-F238E27FC236}">
-                <a16:creationId xmlns:a16="http://schemas.microsoft.com/office/drawing/2014/main" id="{82FB84CD-E0C4-77A7-2D16-AB5ABE60F4A3}"/>
+                <a16:creationId xmlns:a16="http://schemas.microsoft.com/office/drawing/2014/main" id="{01931F55-B17A-6547-D1B0-5A2BB85C6412}"/>
               </a:ext>
             </a:extLst>
           </p:cNvPr>
@@ -920,7 +922,7 @@
           <a:bodyPr/>
           <a:lstStyle/>
           <a:p>
-            <a:fld id="{1D7225A6-8455-47B9-AB87-26931A7E0C65}" type="slidenum">
+            <a:fld id="{13B1E2B3-EF09-4EBF-B449-23BBEF5D6C12}" type="slidenum">
               <a:rPr lang="en-IN" smtClean="0"/>
               <a:t>‹#›</a:t>
             </a:fld>
@@ -931,7 +933,7 @@
     </p:spTree>
     <p:extLst>
       <p:ext uri="{BB962C8B-B14F-4D97-AF65-F5344CB8AC3E}">
-        <p14:creationId xmlns:p14="http://schemas.microsoft.com/office/powerpoint/2010/main" val="926641268"/>
+        <p14:creationId xmlns:p14="http://schemas.microsoft.com/office/powerpoint/2010/main" val="1160621686"/>
       </p:ext>
     </p:extLst>
   </p:cSld>
@@ -963,7 +965,7 @@
           <p:cNvPr id="2" name="Title 1">
             <a:extLst>
               <a:ext uri="{FF2B5EF4-FFF2-40B4-BE49-F238E27FC236}">
-                <a16:creationId xmlns:a16="http://schemas.microsoft.com/office/drawing/2014/main" id="{2029825F-9924-59AF-8887-DFF5B9DC4D3A}"/>
+                <a16:creationId xmlns:a16="http://schemas.microsoft.com/office/drawing/2014/main" id="{49F706A8-6107-2387-3B5D-A04E7A8CBB77}"/>
               </a:ext>
             </a:extLst>
           </p:cNvPr>
@@ -1001,7 +1003,7 @@
           <p:cNvPr id="3" name="Text Placeholder 2">
             <a:extLst>
               <a:ext uri="{FF2B5EF4-FFF2-40B4-BE49-F238E27FC236}">
-                <a16:creationId xmlns:a16="http://schemas.microsoft.com/office/drawing/2014/main" id="{20961949-B65C-12AD-FB9F-5DE8CF086375}"/>
+                <a16:creationId xmlns:a16="http://schemas.microsoft.com/office/drawing/2014/main" id="{2CCF594C-B100-83FF-0E33-AC1E47D77127}"/>
               </a:ext>
             </a:extLst>
           </p:cNvPr>
@@ -1126,7 +1128,7 @@
           <p:cNvPr id="4" name="Date Placeholder 3">
             <a:extLst>
               <a:ext uri="{FF2B5EF4-FFF2-40B4-BE49-F238E27FC236}">
-                <a16:creationId xmlns:a16="http://schemas.microsoft.com/office/drawing/2014/main" id="{1DB642CC-E0B9-A44A-3A1D-748B6ACFD328}"/>
+                <a16:creationId xmlns:a16="http://schemas.microsoft.com/office/drawing/2014/main" id="{7A280EAF-79C6-AB96-381C-1CB1CBB095D5}"/>
               </a:ext>
             </a:extLst>
           </p:cNvPr>
@@ -1142,9 +1144,9 @@
           <a:bodyPr/>
           <a:lstStyle/>
           <a:p>
-            <a:fld id="{7F840261-00B1-4F86-8DD0-5B727C2002AD}" type="datetimeFigureOut">
+            <a:fld id="{E54C691A-9324-4AF1-A836-5C73D2BDC322}" type="datetimeFigureOut">
               <a:rPr lang="en-IN" smtClean="0"/>
-              <a:t>05-10-2026</a:t>
+              <a:t>19-10-2026</a:t>
             </a:fld>
             <a:endParaRPr lang="en-IN"/>
           </a:p>
@@ -1155,7 +1157,7 @@
           <p:cNvPr id="5" name="Footer Placeholder 4">
             <a:extLst>
               <a:ext uri="{FF2B5EF4-FFF2-40B4-BE49-F238E27FC236}">
-                <a16:creationId xmlns:a16="http://schemas.microsoft.com/office/drawing/2014/main" id="{68955FED-4D25-46EE-2E35-366232B084EA}"/>
+                <a16:creationId xmlns:a16="http://schemas.microsoft.com/office/drawing/2014/main" id="{89515CA8-13EC-511E-4619-72F716145E9A}"/>
               </a:ext>
             </a:extLst>
           </p:cNvPr>
@@ -1180,7 +1182,7 @@
           <p:cNvPr id="6" name="Slide Number Placeholder 5">
             <a:extLst>
               <a:ext uri="{FF2B5EF4-FFF2-40B4-BE49-F238E27FC236}">
-                <a16:creationId xmlns:a16="http://schemas.microsoft.com/office/drawing/2014/main" id="{D9722123-5406-3749-6DD6-CDFBBD019248}"/>
+                <a16:creationId xmlns:a16="http://schemas.microsoft.com/office/drawing/2014/main" id="{6FCB6D81-B89A-F3F4-FED8-FF722770C59D}"/>
               </a:ext>
             </a:extLst>
           </p:cNvPr>
@@ -1196,7 +1198,7 @@
           <a:bodyPr/>
           <a:lstStyle/>
           <a:p>
-            <a:fld id="{1D7225A6-8455-47B9-AB87-26931A7E0C65}" type="slidenum">
+            <a:fld id="{13B1E2B3-EF09-4EBF-B449-23BBEF5D6C12}" type="slidenum">
               <a:rPr lang="en-IN" smtClean="0"/>
               <a:t>‹#›</a:t>
             </a:fld>
@@ -1207,7 +1209,7 @@
     </p:spTree>
     <p:extLst>
       <p:ext uri="{BB962C8B-B14F-4D97-AF65-F5344CB8AC3E}">
-        <p14:creationId xmlns:p14="http://schemas.microsoft.com/office/powerpoint/2010/main" val="4269601402"/>
+        <p14:creationId xmlns:p14="http://schemas.microsoft.com/office/powerpoint/2010/main" val="3737344479"/>
       </p:ext>
     </p:extLst>
   </p:cSld>
@@ -1239,7 +1241,7 @@
           <p:cNvPr id="2" name="Title 1">
             <a:extLst>
               <a:ext uri="{FF2B5EF4-FFF2-40B4-BE49-F238E27FC236}">
-                <a16:creationId xmlns:a16="http://schemas.microsoft.com/office/drawing/2014/main" id="{B4BB5E91-AD0C-1A1E-5E26-908E9FA2E218}"/>
+                <a16:creationId xmlns:a16="http://schemas.microsoft.com/office/drawing/2014/main" id="{FB00EEB0-779B-3CCB-4902-F45FDFF51286}"/>
               </a:ext>
             </a:extLst>
           </p:cNvPr>
@@ -1268,7 +1270,7 @@
           <p:cNvPr id="3" name="Content Placeholder 2">
             <a:extLst>
               <a:ext uri="{FF2B5EF4-FFF2-40B4-BE49-F238E27FC236}">
-                <a16:creationId xmlns:a16="http://schemas.microsoft.com/office/drawing/2014/main" id="{DE7C36AB-70E0-B296-E8AB-7567EA2B0E5F}"/>
+                <a16:creationId xmlns:a16="http://schemas.microsoft.com/office/drawing/2014/main" id="{79BCFB3B-F4C8-A9CA-75A2-478A14450274}"/>
               </a:ext>
             </a:extLst>
           </p:cNvPr>
@@ -1331,7 +1333,7 @@
           <p:cNvPr id="4" name="Content Placeholder 3">
             <a:extLst>
               <a:ext uri="{FF2B5EF4-FFF2-40B4-BE49-F238E27FC236}">
-                <a16:creationId xmlns:a16="http://schemas.microsoft.com/office/drawing/2014/main" id="{42609BFB-6B31-9C89-2EB8-7D858B3A3681}"/>
+                <a16:creationId xmlns:a16="http://schemas.microsoft.com/office/drawing/2014/main" id="{85775E47-4650-8090-7322-613925F05C72}"/>
               </a:ext>
             </a:extLst>
           </p:cNvPr>
@@ -1394,7 +1396,7 @@
           <p:cNvPr id="5" name="Date Placeholder 4">
             <a:extLst>
               <a:ext uri="{FF2B5EF4-FFF2-40B4-BE49-F238E27FC236}">
-                <a16:creationId xmlns:a16="http://schemas.microsoft.com/office/drawing/2014/main" id="{F68ED176-D149-7C1A-3950-56264E7AC2EB}"/>
+                <a16:creationId xmlns:a16="http://schemas.microsoft.com/office/drawing/2014/main" id="{BC0E87B6-C835-E4EE-ED5E-216C38FC8262}"/>
               </a:ext>
             </a:extLst>
           </p:cNvPr>
@@ -1410,9 +1412,9 @@
           <a:bodyPr/>
           <a:lstStyle/>
           <a:p>
-            <a:fld id="{7F840261-00B1-4F86-8DD0-5B727C2002AD}" type="datetimeFigureOut">
+            <a:fld id="{E54C691A-9324-4AF1-A836-5C73D2BDC322}" type="datetimeFigureOut">
               <a:rPr lang="en-IN" smtClean="0"/>
-              <a:t>05-10-2026</a:t>
+              <a:t>19-10-2026</a:t>
             </a:fld>
             <a:endParaRPr lang="en-IN"/>
           </a:p>
@@ -1423,7 +1425,7 @@
           <p:cNvPr id="6" name="Footer Placeholder 5">
             <a:extLst>
               <a:ext uri="{FF2B5EF4-FFF2-40B4-BE49-F238E27FC236}">
-                <a16:creationId xmlns:a16="http://schemas.microsoft.com/office/drawing/2014/main" id="{98DC4CEA-9240-ED69-AFC1-EC6BB2B4E3F9}"/>
+                <a16:creationId xmlns:a16="http://schemas.microsoft.com/office/drawing/2014/main" id="{E43D799A-ED36-5505-4D3D-94295803C3A5}"/>
               </a:ext>
             </a:extLst>
           </p:cNvPr>
@@ -1448,7 +1450,7 @@
           <p:cNvPr id="7" name="Slide Number Placeholder 6">
             <a:extLst>
               <a:ext uri="{FF2B5EF4-FFF2-40B4-BE49-F238E27FC236}">
-                <a16:creationId xmlns:a16="http://schemas.microsoft.com/office/drawing/2014/main" id="{79904FD7-D6FF-8298-E3AC-7B9159C254A1}"/>
+                <a16:creationId xmlns:a16="http://schemas.microsoft.com/office/drawing/2014/main" id="{0E6B9A20-F6C9-3BD9-AFFB-C94CA55DCDB4}"/>
               </a:ext>
             </a:extLst>
           </p:cNvPr>
@@ -1464,7 +1466,7 @@
           <a:bodyPr/>
           <a:lstStyle/>
           <a:p>
-            <a:fld id="{1D7225A6-8455-47B9-AB87-26931A7E0C65}" type="slidenum">
+            <a:fld id="{13B1E2B3-EF09-4EBF-B449-23BBEF5D6C12}" type="slidenum">
               <a:rPr lang="en-IN" smtClean="0"/>
               <a:t>‹#›</a:t>
             </a:fld>
@@ -1475,7 +1477,7 @@
     </p:spTree>
     <p:extLst>
       <p:ext uri="{BB962C8B-B14F-4D97-AF65-F5344CB8AC3E}">
-        <p14:creationId xmlns:p14="http://schemas.microsoft.com/office/powerpoint/2010/main" val="3897464056"/>
+        <p14:creationId xmlns:p14="http://schemas.microsoft.com/office/powerpoint/2010/main" val="3356795504"/>
       </p:ext>
     </p:extLst>
   </p:cSld>
@@ -1507,7 +1509,7 @@
           <p:cNvPr id="2" name="Title 1">
             <a:extLst>
               <a:ext uri="{FF2B5EF4-FFF2-40B4-BE49-F238E27FC236}">
-                <a16:creationId xmlns:a16="http://schemas.microsoft.com/office/drawing/2014/main" id="{04A01538-26B1-A21A-7C4D-C89255166818}"/>
+                <a16:creationId xmlns:a16="http://schemas.microsoft.com/office/drawing/2014/main" id="{779BD83D-34B9-DFAE-14C8-433A0C108A80}"/>
               </a:ext>
             </a:extLst>
           </p:cNvPr>
@@ -1541,7 +1543,7 @@
           <p:cNvPr id="3" name="Text Placeholder 2">
             <a:extLst>
               <a:ext uri="{FF2B5EF4-FFF2-40B4-BE49-F238E27FC236}">
-                <a16:creationId xmlns:a16="http://schemas.microsoft.com/office/drawing/2014/main" id="{5DC0E2AE-26D3-4B9F-C50D-808157602242}"/>
+                <a16:creationId xmlns:a16="http://schemas.microsoft.com/office/drawing/2014/main" id="{C4996A08-5AC6-BCE7-E722-C624E3CDB5D4}"/>
               </a:ext>
             </a:extLst>
           </p:cNvPr>
@@ -1612,7 +1614,7 @@
           <p:cNvPr id="4" name="Content Placeholder 3">
             <a:extLst>
               <a:ext uri="{FF2B5EF4-FFF2-40B4-BE49-F238E27FC236}">
-                <a16:creationId xmlns:a16="http://schemas.microsoft.com/office/drawing/2014/main" id="{316130CE-5298-F69E-D064-30A728A03E77}"/>
+                <a16:creationId xmlns:a16="http://schemas.microsoft.com/office/drawing/2014/main" id="{59CFC63A-72B2-49DB-B5FC-0B7AC84B9BC3}"/>
               </a:ext>
             </a:extLst>
           </p:cNvPr>
@@ -1675,7 +1677,7 @@
           <p:cNvPr id="5" name="Text Placeholder 4">
             <a:extLst>
               <a:ext uri="{FF2B5EF4-FFF2-40B4-BE49-F238E27FC236}">
-                <a16:creationId xmlns:a16="http://schemas.microsoft.com/office/drawing/2014/main" id="{C879268E-CC78-0E6C-F50E-A322CD850745}"/>
+                <a16:creationId xmlns:a16="http://schemas.microsoft.com/office/drawing/2014/main" id="{5CFD72C3-FBD9-7A64-15AC-54BFDB3263BC}"/>
               </a:ext>
             </a:extLst>
           </p:cNvPr>
@@ -1746,7 +1748,7 @@
           <p:cNvPr id="6" name="Content Placeholder 5">
             <a:extLst>
               <a:ext uri="{FF2B5EF4-FFF2-40B4-BE49-F238E27FC236}">
-                <a16:creationId xmlns:a16="http://schemas.microsoft.com/office/drawing/2014/main" id="{D7A0CC52-98A2-5883-0458-88F0472EE185}"/>
+                <a16:creationId xmlns:a16="http://schemas.microsoft.com/office/drawing/2014/main" id="{71407407-92E1-C648-DAEA-AA3D11B936DF}"/>
               </a:ext>
             </a:extLst>
           </p:cNvPr>
@@ -1809,7 +1811,7 @@
           <p:cNvPr id="7" name="Date Placeholder 6">
             <a:extLst>
               <a:ext uri="{FF2B5EF4-FFF2-40B4-BE49-F238E27FC236}">
-                <a16:creationId xmlns:a16="http://schemas.microsoft.com/office/drawing/2014/main" id="{5B21A4AE-EB91-F17F-D08C-620C9D5D7CED}"/>
+                <a16:creationId xmlns:a16="http://schemas.microsoft.com/office/drawing/2014/main" id="{E8381C3D-F35D-BF7B-1886-812794CACF9F}"/>
               </a:ext>
             </a:extLst>
           </p:cNvPr>
@@ -1825,9 +1827,9 @@
           <a:bodyPr/>
           <a:lstStyle/>
           <a:p>
-            <a:fld id="{7F840261-00B1-4F86-8DD0-5B727C2002AD}" type="datetimeFigureOut">
+            <a:fld id="{E54C691A-9324-4AF1-A836-5C73D2BDC322}" type="datetimeFigureOut">
               <a:rPr lang="en-IN" smtClean="0"/>
-              <a:t>05-10-2026</a:t>
+              <a:t>19-10-2026</a:t>
             </a:fld>
             <a:endParaRPr lang="en-IN"/>
           </a:p>
@@ -1838,7 +1840,7 @@
           <p:cNvPr id="8" name="Footer Placeholder 7">
             <a:extLst>
               <a:ext uri="{FF2B5EF4-FFF2-40B4-BE49-F238E27FC236}">
-                <a16:creationId xmlns:a16="http://schemas.microsoft.com/office/drawing/2014/main" id="{6BB601A6-D0D0-9987-C397-1B8884BB5C1C}"/>
+                <a16:creationId xmlns:a16="http://schemas.microsoft.com/office/drawing/2014/main" id="{021B2634-A6BB-46CB-BE6C-7E8860D2C746}"/>
               </a:ext>
             </a:extLst>
           </p:cNvPr>
@@ -1863,7 +1865,7 @@
           <p:cNvPr id="9" name="Slide Number Placeholder 8">
             <a:extLst>
               <a:ext uri="{FF2B5EF4-FFF2-40B4-BE49-F238E27FC236}">
-                <a16:creationId xmlns:a16="http://schemas.microsoft.com/office/drawing/2014/main" id="{794279B3-786C-AB65-9AD1-75E0CBDC4EAD}"/>
+                <a16:creationId xmlns:a16="http://schemas.microsoft.com/office/drawing/2014/main" id="{EDF079BE-0094-4599-C2B2-955629A3AB44}"/>
               </a:ext>
             </a:extLst>
           </p:cNvPr>
@@ -1879,7 +1881,7 @@
           <a:bodyPr/>
           <a:lstStyle/>
           <a:p>
-            <a:fld id="{1D7225A6-8455-47B9-AB87-26931A7E0C65}" type="slidenum">
+            <a:fld id="{13B1E2B3-EF09-4EBF-B449-23BBEF5D6C12}" type="slidenum">
               <a:rPr lang="en-IN" smtClean="0"/>
               <a:t>‹#›</a:t>
             </a:fld>
@@ -1890,7 +1892,7 @@
     </p:spTree>
     <p:extLst>
       <p:ext uri="{BB962C8B-B14F-4D97-AF65-F5344CB8AC3E}">
-        <p14:creationId xmlns:p14="http://schemas.microsoft.com/office/powerpoint/2010/main" val="2563074242"/>
+        <p14:creationId xmlns:p14="http://schemas.microsoft.com/office/powerpoint/2010/main" val="2687707064"/>
       </p:ext>
     </p:extLst>
   </p:cSld>
@@ -1922,7 +1924,7 @@
           <p:cNvPr id="2" name="Title 1">
             <a:extLst>
               <a:ext uri="{FF2B5EF4-FFF2-40B4-BE49-F238E27FC236}">
-                <a16:creationId xmlns:a16="http://schemas.microsoft.com/office/drawing/2014/main" id="{55AD637C-7C5A-768C-90DA-9366FE73E741}"/>
+                <a16:creationId xmlns:a16="http://schemas.microsoft.com/office/drawing/2014/main" id="{3C9C4C48-F9C7-78B0-1B4B-AA447FBA33C3}"/>
               </a:ext>
             </a:extLst>
           </p:cNvPr>
@@ -1951,7 +1953,7 @@
           <p:cNvPr id="3" name="Date Placeholder 2">
             <a:extLst>
               <a:ext uri="{FF2B5EF4-FFF2-40B4-BE49-F238E27FC236}">
-                <a16:creationId xmlns:a16="http://schemas.microsoft.com/office/drawing/2014/main" id="{5EAE6813-2842-34E1-D440-759C617D17E9}"/>
+                <a16:creationId xmlns:a16="http://schemas.microsoft.com/office/drawing/2014/main" id="{AD1F7198-8F64-D8A5-F557-4CB6CD0859B9}"/>
               </a:ext>
             </a:extLst>
           </p:cNvPr>
@@ -1967,9 +1969,9 @@
           <a:bodyPr/>
           <a:lstStyle/>
           <a:p>
-            <a:fld id="{7F840261-00B1-4F86-8DD0-5B727C2002AD}" type="datetimeFigureOut">
+            <a:fld id="{E54C691A-9324-4AF1-A836-5C73D2BDC322}" type="datetimeFigureOut">
               <a:rPr lang="en-IN" smtClean="0"/>
-              <a:t>05-10-2026</a:t>
+              <a:t>19-10-2026</a:t>
             </a:fld>
             <a:endParaRPr lang="en-IN"/>
           </a:p>
@@ -1980,7 +1982,7 @@
           <p:cNvPr id="4" name="Footer Placeholder 3">
             <a:extLst>
               <a:ext uri="{FF2B5EF4-FFF2-40B4-BE49-F238E27FC236}">
-                <a16:creationId xmlns:a16="http://schemas.microsoft.com/office/drawing/2014/main" id="{D3FA79F9-901A-4E59-31AA-B34F7F4D27F2}"/>
+                <a16:creationId xmlns:a16="http://schemas.microsoft.com/office/drawing/2014/main" id="{AA8228F2-1ED7-45A7-491A-C8FE628A3F76}"/>
               </a:ext>
             </a:extLst>
           </p:cNvPr>
@@ -2005,7 +2007,7 @@
           <p:cNvPr id="5" name="Slide Number Placeholder 4">
             <a:extLst>
               <a:ext uri="{FF2B5EF4-FFF2-40B4-BE49-F238E27FC236}">
-                <a16:creationId xmlns:a16="http://schemas.microsoft.com/office/drawing/2014/main" id="{A7AF5F00-9E7C-C477-9A4E-1242BBF450F0}"/>
+                <a16:creationId xmlns:a16="http://schemas.microsoft.com/office/drawing/2014/main" id="{8C38A3D5-E652-929A-C13D-0390C5C819EB}"/>
               </a:ext>
             </a:extLst>
           </p:cNvPr>
@@ -2021,7 +2023,7 @@
           <a:bodyPr/>
           <a:lstStyle/>
           <a:p>
-            <a:fld id="{1D7225A6-8455-47B9-AB87-26931A7E0C65}" type="slidenum">
+            <a:fld id="{13B1E2B3-EF09-4EBF-B449-23BBEF5D6C12}" type="slidenum">
               <a:rPr lang="en-IN" smtClean="0"/>
               <a:t>‹#›</a:t>
             </a:fld>
@@ -2032,7 +2034,7 @@
     </p:spTree>
     <p:extLst>
       <p:ext uri="{BB962C8B-B14F-4D97-AF65-F5344CB8AC3E}">
-        <p14:creationId xmlns:p14="http://schemas.microsoft.com/office/powerpoint/2010/main" val="2104979377"/>
+        <p14:creationId xmlns:p14="http://schemas.microsoft.com/office/powerpoint/2010/main" val="1752337225"/>
       </p:ext>
     </p:extLst>
   </p:cSld>
@@ -2064,7 +2066,7 @@
           <p:cNvPr id="2" name="Date Placeholder 1">
             <a:extLst>
               <a:ext uri="{FF2B5EF4-FFF2-40B4-BE49-F238E27FC236}">
-                <a16:creationId xmlns:a16="http://schemas.microsoft.com/office/drawing/2014/main" id="{3DAAF619-9E77-F0DF-FF7F-DCB3DF26072E}"/>
+                <a16:creationId xmlns:a16="http://schemas.microsoft.com/office/drawing/2014/main" id="{7747E047-0FD4-5F9D-69C6-4A32DB4A1136}"/>
               </a:ext>
             </a:extLst>
           </p:cNvPr>
@@ -2080,9 +2082,9 @@
           <a:bodyPr/>
           <a:lstStyle/>
           <a:p>
-            <a:fld id="{7F840261-00B1-4F86-8DD0-5B727C2002AD}" type="datetimeFigureOut">
+            <a:fld id="{E54C691A-9324-4AF1-A836-5C73D2BDC322}" type="datetimeFigureOut">
               <a:rPr lang="en-IN" smtClean="0"/>
-              <a:t>05-10-2026</a:t>
+              <a:t>19-10-2026</a:t>
             </a:fld>
             <a:endParaRPr lang="en-IN"/>
           </a:p>
@@ -2093,7 +2095,7 @@
           <p:cNvPr id="3" name="Footer Placeholder 2">
             <a:extLst>
               <a:ext uri="{FF2B5EF4-FFF2-40B4-BE49-F238E27FC236}">
-                <a16:creationId xmlns:a16="http://schemas.microsoft.com/office/drawing/2014/main" id="{8D9F1D22-6E39-2CAE-4DB1-2B6AA52097F9}"/>
+                <a16:creationId xmlns:a16="http://schemas.microsoft.com/office/drawing/2014/main" id="{5BEA3F6C-4525-CF1B-BA23-F20E296327EC}"/>
               </a:ext>
             </a:extLst>
           </p:cNvPr>
@@ -2118,7 +2120,7 @@
           <p:cNvPr id="4" name="Slide Number Placeholder 3">
             <a:extLst>
               <a:ext uri="{FF2B5EF4-FFF2-40B4-BE49-F238E27FC236}">
-                <a16:creationId xmlns:a16="http://schemas.microsoft.com/office/drawing/2014/main" id="{AC45349A-255F-C2DA-9623-6AAC8DD0B6AA}"/>
+                <a16:creationId xmlns:a16="http://schemas.microsoft.com/office/drawing/2014/main" id="{48A9147E-051D-5F2B-89D6-A153A173A795}"/>
               </a:ext>
             </a:extLst>
           </p:cNvPr>
@@ -2134,7 +2136,7 @@
           <a:bodyPr/>
           <a:lstStyle/>
           <a:p>
-            <a:fld id="{1D7225A6-8455-47B9-AB87-26931A7E0C65}" type="slidenum">
+            <a:fld id="{13B1E2B3-EF09-4EBF-B449-23BBEF5D6C12}" type="slidenum">
               <a:rPr lang="en-IN" smtClean="0"/>
               <a:t>‹#›</a:t>
             </a:fld>
@@ -2145,7 +2147,7 @@
     </p:spTree>
     <p:extLst>
       <p:ext uri="{BB962C8B-B14F-4D97-AF65-F5344CB8AC3E}">
-        <p14:creationId xmlns:p14="http://schemas.microsoft.com/office/powerpoint/2010/main" val="1698709340"/>
+        <p14:creationId xmlns:p14="http://schemas.microsoft.com/office/powerpoint/2010/main" val="2772845422"/>
       </p:ext>
     </p:extLst>
   </p:cSld>
@@ -2177,7 +2179,7 @@
           <p:cNvPr id="2" name="Title 1">
             <a:extLst>
               <a:ext uri="{FF2B5EF4-FFF2-40B4-BE49-F238E27FC236}">
-                <a16:creationId xmlns:a16="http://schemas.microsoft.com/office/drawing/2014/main" id="{546549E7-C968-2F85-E20B-F5D304E1E9ED}"/>
+                <a16:creationId xmlns:a16="http://schemas.microsoft.com/office/drawing/2014/main" id="{B6A345AF-7AC3-5E6E-29FB-04AB1EA19DBF}"/>
               </a:ext>
             </a:extLst>
           </p:cNvPr>
@@ -2215,7 +2217,7 @@
           <p:cNvPr id="3" name="Content Placeholder 2">
             <a:extLst>
               <a:ext uri="{FF2B5EF4-FFF2-40B4-BE49-F238E27FC236}">
-                <a16:creationId xmlns:a16="http://schemas.microsoft.com/office/drawing/2014/main" id="{D0B2B970-D19C-A46D-85B2-FCD9163EE468}"/>
+                <a16:creationId xmlns:a16="http://schemas.microsoft.com/office/drawing/2014/main" id="{DABF9E15-10DB-C029-D168-47EF87A0FD3E}"/>
               </a:ext>
             </a:extLst>
           </p:cNvPr>
@@ -2306,7 +2308,7 @@
           <p:cNvPr id="4" name="Text Placeholder 3">
             <a:extLst>
               <a:ext uri="{FF2B5EF4-FFF2-40B4-BE49-F238E27FC236}">
-                <a16:creationId xmlns:a16="http://schemas.microsoft.com/office/drawing/2014/main" id="{81868421-F445-F794-7F66-172A991872CA}"/>
+                <a16:creationId xmlns:a16="http://schemas.microsoft.com/office/drawing/2014/main" id="{5F333989-5AF8-5FBD-9600-A79EAD60C81C}"/>
               </a:ext>
             </a:extLst>
           </p:cNvPr>
@@ -2377,7 +2379,7 @@
           <p:cNvPr id="5" name="Date Placeholder 4">
             <a:extLst>
               <a:ext uri="{FF2B5EF4-FFF2-40B4-BE49-F238E27FC236}">
-                <a16:creationId xmlns:a16="http://schemas.microsoft.com/office/drawing/2014/main" id="{C6F137F3-841E-086F-FBD2-7929C7B1D977}"/>
+                <a16:creationId xmlns:a16="http://schemas.microsoft.com/office/drawing/2014/main" id="{19AB021E-7F26-85D9-4C5E-4D04C1851E1F}"/>
               </a:ext>
             </a:extLst>
           </p:cNvPr>
@@ -2393,9 +2395,9 @@
           <a:bodyPr/>
           <a:lstStyle/>
           <a:p>
-            <a:fld id="{7F840261-00B1-4F86-8DD0-5B727C2002AD}" type="datetimeFigureOut">
+            <a:fld id="{E54C691A-9324-4AF1-A836-5C73D2BDC322}" type="datetimeFigureOut">
               <a:rPr lang="en-IN" smtClean="0"/>
-              <a:t>05-10-2026</a:t>
+              <a:t>19-10-2026</a:t>
             </a:fld>
             <a:endParaRPr lang="en-IN"/>
           </a:p>
@@ -2406,7 +2408,7 @@
           <p:cNvPr id="6" name="Footer Placeholder 5">
             <a:extLst>
               <a:ext uri="{FF2B5EF4-FFF2-40B4-BE49-F238E27FC236}">
-                <a16:creationId xmlns:a16="http://schemas.microsoft.com/office/drawing/2014/main" id="{3F36013C-0D68-A011-4C05-70064A3AC9E0}"/>
+                <a16:creationId xmlns:a16="http://schemas.microsoft.com/office/drawing/2014/main" id="{CA52DE87-5B53-EA96-C487-D049FDF03AEF}"/>
               </a:ext>
             </a:extLst>
           </p:cNvPr>
@@ -2431,7 +2433,7 @@
           <p:cNvPr id="7" name="Slide Number Placeholder 6">
             <a:extLst>
               <a:ext uri="{FF2B5EF4-FFF2-40B4-BE49-F238E27FC236}">
-                <a16:creationId xmlns:a16="http://schemas.microsoft.com/office/drawing/2014/main" id="{7B7058C9-DCF7-437B-FE2D-B871A211E7B0}"/>
+                <a16:creationId xmlns:a16="http://schemas.microsoft.com/office/drawing/2014/main" id="{CA5BEF25-3168-AB9B-30D5-595BB2C5385B}"/>
               </a:ext>
             </a:extLst>
           </p:cNvPr>
@@ -2447,7 +2449,7 @@
           <a:bodyPr/>
           <a:lstStyle/>
           <a:p>
-            <a:fld id="{1D7225A6-8455-47B9-AB87-26931A7E0C65}" type="slidenum">
+            <a:fld id="{13B1E2B3-EF09-4EBF-B449-23BBEF5D6C12}" type="slidenum">
               <a:rPr lang="en-IN" smtClean="0"/>
               <a:t>‹#›</a:t>
             </a:fld>
@@ -2458,7 +2460,7 @@
     </p:spTree>
     <p:extLst>
       <p:ext uri="{BB962C8B-B14F-4D97-AF65-F5344CB8AC3E}">
-        <p14:creationId xmlns:p14="http://schemas.microsoft.com/office/powerpoint/2010/main" val="1336474702"/>
+        <p14:creationId xmlns:p14="http://schemas.microsoft.com/office/powerpoint/2010/main" val="1746450693"/>
       </p:ext>
     </p:extLst>
   </p:cSld>
@@ -2490,7 +2492,7 @@
           <p:cNvPr id="2" name="Title 1">
             <a:extLst>
               <a:ext uri="{FF2B5EF4-FFF2-40B4-BE49-F238E27FC236}">
-                <a16:creationId xmlns:a16="http://schemas.microsoft.com/office/drawing/2014/main" id="{08A76151-C999-204A-12C2-53268D506377}"/>
+                <a16:creationId xmlns:a16="http://schemas.microsoft.com/office/drawing/2014/main" id="{C74ECE66-75EC-D6EE-2EAD-12292F3A85EF}"/>
               </a:ext>
             </a:extLst>
           </p:cNvPr>
@@ -2528,7 +2530,7 @@
           <p:cNvPr id="3" name="Picture Placeholder 2">
             <a:extLst>
               <a:ext uri="{FF2B5EF4-FFF2-40B4-BE49-F238E27FC236}">
-                <a16:creationId xmlns:a16="http://schemas.microsoft.com/office/drawing/2014/main" id="{22D98AD7-9279-2F00-4556-0511786144C2}"/>
+                <a16:creationId xmlns:a16="http://schemas.microsoft.com/office/drawing/2014/main" id="{32BAB0CE-51F4-3B87-759F-52D076183CEF}"/>
               </a:ext>
             </a:extLst>
           </p:cNvPr>
@@ -2595,7 +2597,7 @@
           <p:cNvPr id="4" name="Text Placeholder 3">
             <a:extLst>
               <a:ext uri="{FF2B5EF4-FFF2-40B4-BE49-F238E27FC236}">
-                <a16:creationId xmlns:a16="http://schemas.microsoft.com/office/drawing/2014/main" id="{0E46F488-F2D2-D7FD-84D3-369F67C7C225}"/>
+                <a16:creationId xmlns:a16="http://schemas.microsoft.com/office/drawing/2014/main" id="{5F91A479-107D-2846-86A1-026B28316038}"/>
               </a:ext>
             </a:extLst>
           </p:cNvPr>
@@ -2666,7 +2668,7 @@
           <p:cNvPr id="5" name="Date Placeholder 4">
             <a:extLst>
               <a:ext uri="{FF2B5EF4-FFF2-40B4-BE49-F238E27FC236}">
-                <a16:creationId xmlns:a16="http://schemas.microsoft.com/office/drawing/2014/main" id="{69A53925-C44A-8E7F-845F-F4BD677F5167}"/>
+                <a16:creationId xmlns:a16="http://schemas.microsoft.com/office/drawing/2014/main" id="{7E9AD07F-962D-474E-F5E8-5FF5C4D8E034}"/>
               </a:ext>
             </a:extLst>
           </p:cNvPr>
@@ -2682,9 +2684,9 @@
           <a:bodyPr/>
           <a:lstStyle/>
           <a:p>
-            <a:fld id="{7F840261-00B1-4F86-8DD0-5B727C2002AD}" type="datetimeFigureOut">
+            <a:fld id="{E54C691A-9324-4AF1-A836-5C73D2BDC322}" type="datetimeFigureOut">
               <a:rPr lang="en-IN" smtClean="0"/>
-              <a:t>05-10-2026</a:t>
+              <a:t>19-10-2026</a:t>
             </a:fld>
             <a:endParaRPr lang="en-IN"/>
           </a:p>
@@ -2695,7 +2697,7 @@
           <p:cNvPr id="6" name="Footer Placeholder 5">
             <a:extLst>
               <a:ext uri="{FF2B5EF4-FFF2-40B4-BE49-F238E27FC236}">
-                <a16:creationId xmlns:a16="http://schemas.microsoft.com/office/drawing/2014/main" id="{C3C4EF42-2F8F-2DAD-CD41-E353A1532B88}"/>
+                <a16:creationId xmlns:a16="http://schemas.microsoft.com/office/drawing/2014/main" id="{BF0C5046-2358-C82E-4677-1C29799B15F1}"/>
               </a:ext>
             </a:extLst>
           </p:cNvPr>
@@ -2720,7 +2722,7 @@
           <p:cNvPr id="7" name="Slide Number Placeholder 6">
             <a:extLst>
               <a:ext uri="{FF2B5EF4-FFF2-40B4-BE49-F238E27FC236}">
-                <a16:creationId xmlns:a16="http://schemas.microsoft.com/office/drawing/2014/main" id="{6E8518C9-CEF6-2E11-7785-A4AF23B0E92D}"/>
+                <a16:creationId xmlns:a16="http://schemas.microsoft.com/office/drawing/2014/main" id="{7160CE12-97DE-DEE7-D7F4-923D79888AD3}"/>
               </a:ext>
             </a:extLst>
           </p:cNvPr>
@@ -2736,7 +2738,7 @@
           <a:bodyPr/>
           <a:lstStyle/>
           <a:p>
-            <a:fld id="{1D7225A6-8455-47B9-AB87-26931A7E0C65}" type="slidenum">
+            <a:fld id="{13B1E2B3-EF09-4EBF-B449-23BBEF5D6C12}" type="slidenum">
               <a:rPr lang="en-IN" smtClean="0"/>
               <a:t>‹#›</a:t>
             </a:fld>
@@ -2747,7 +2749,7 @@
     </p:spTree>
     <p:extLst>
       <p:ext uri="{BB962C8B-B14F-4D97-AF65-F5344CB8AC3E}">
-        <p14:creationId xmlns:p14="http://schemas.microsoft.com/office/powerpoint/2010/main" val="4191188202"/>
+        <p14:creationId xmlns:p14="http://schemas.microsoft.com/office/powerpoint/2010/main" val="3489078932"/>
       </p:ext>
     </p:extLst>
   </p:cSld>
@@ -2784,7 +2786,7 @@
           <p:cNvPr id="2" name="Title Placeholder 1">
             <a:extLst>
               <a:ext uri="{FF2B5EF4-FFF2-40B4-BE49-F238E27FC236}">
-                <a16:creationId xmlns:a16="http://schemas.microsoft.com/office/drawing/2014/main" id="{126593E1-CECC-92D2-88D7-A6E1AAD0CD4F}"/>
+                <a16:creationId xmlns:a16="http://schemas.microsoft.com/office/drawing/2014/main" id="{2EAB0D6E-875F-D720-6E4A-896CE2A434DD}"/>
               </a:ext>
             </a:extLst>
           </p:cNvPr>
@@ -2823,7 +2825,7 @@
           <p:cNvPr id="3" name="Text Placeholder 2">
             <a:extLst>
               <a:ext uri="{FF2B5EF4-FFF2-40B4-BE49-F238E27FC236}">
-                <a16:creationId xmlns:a16="http://schemas.microsoft.com/office/drawing/2014/main" id="{D5A2C444-2D1D-76D3-8A69-7D3331900182}"/>
+                <a16:creationId xmlns:a16="http://schemas.microsoft.com/office/drawing/2014/main" id="{7107A659-3C0F-14B2-6CF5-C65F9FB84D67}"/>
               </a:ext>
             </a:extLst>
           </p:cNvPr>
@@ -2891,7 +2893,7 @@
           <p:cNvPr id="4" name="Date Placeholder 3">
             <a:extLst>
               <a:ext uri="{FF2B5EF4-FFF2-40B4-BE49-F238E27FC236}">
-                <a16:creationId xmlns:a16="http://schemas.microsoft.com/office/drawing/2014/main" id="{5A6195DE-0EBD-49B7-F462-88A08CD78045}"/>
+                <a16:creationId xmlns:a16="http://schemas.microsoft.com/office/drawing/2014/main" id="{5FD03335-B190-4A58-9C3C-C9E14DB5BCF7}"/>
               </a:ext>
             </a:extLst>
           </p:cNvPr>
@@ -2925,9 +2927,9 @@
             </a:lvl1pPr>
           </a:lstStyle>
           <a:p>
-            <a:fld id="{7F840261-00B1-4F86-8DD0-5B727C2002AD}" type="datetimeFigureOut">
+            <a:fld id="{E54C691A-9324-4AF1-A836-5C73D2BDC322}" type="datetimeFigureOut">
               <a:rPr lang="en-IN" smtClean="0"/>
-              <a:t>05-10-2026</a:t>
+              <a:t>19-10-2026</a:t>
             </a:fld>
             <a:endParaRPr lang="en-IN"/>
           </a:p>
@@ -2938,7 +2940,7 @@
           <p:cNvPr id="5" name="Footer Placeholder 4">
             <a:extLst>
               <a:ext uri="{FF2B5EF4-FFF2-40B4-BE49-F238E27FC236}">
-                <a16:creationId xmlns:a16="http://schemas.microsoft.com/office/drawing/2014/main" id="{165AC002-F753-B277-EBF9-FAAC28E669C6}"/>
+                <a16:creationId xmlns:a16="http://schemas.microsoft.com/office/drawing/2014/main" id="{13C38FDC-309E-C811-0E4E-84B87254741C}"/>
               </a:ext>
             </a:extLst>
           </p:cNvPr>
@@ -2981,7 +2983,7 @@
           <p:cNvPr id="6" name="Slide Number Placeholder 5">
             <a:extLst>
               <a:ext uri="{FF2B5EF4-FFF2-40B4-BE49-F238E27FC236}">
-                <a16:creationId xmlns:a16="http://schemas.microsoft.com/office/drawing/2014/main" id="{473F5961-CD11-7262-3A74-FA7BC5274FC8}"/>
+                <a16:creationId xmlns:a16="http://schemas.microsoft.com/office/drawing/2014/main" id="{8EF47945-65D1-D54B-FCCB-06C8D206F9A0}"/>
               </a:ext>
             </a:extLst>
           </p:cNvPr>
@@ -3015,7 +3017,7 @@
             </a:lvl1pPr>
           </a:lstStyle>
           <a:p>
-            <a:fld id="{1D7225A6-8455-47B9-AB87-26931A7E0C65}" type="slidenum">
+            <a:fld id="{13B1E2B3-EF09-4EBF-B449-23BBEF5D6C12}" type="slidenum">
               <a:rPr lang="en-IN" smtClean="0"/>
               <a:t>‹#›</a:t>
             </a:fld>
@@ -3026,7 +3028,7 @@
     </p:spTree>
     <p:extLst>
       <p:ext uri="{BB962C8B-B14F-4D97-AF65-F5344CB8AC3E}">
-        <p14:creationId xmlns:p14="http://schemas.microsoft.com/office/powerpoint/2010/main" val="2178842481"/>
+        <p14:creationId xmlns:p14="http://schemas.microsoft.com/office/powerpoint/2010/main" val="2820248777"/>
       </p:ext>
     </p:extLst>
   </p:cSld>
@@ -3349,7 +3351,7 @@
           <p:cNvPr id="2" name="Rectangle 1">
             <a:extLst>
               <a:ext uri="{FF2B5EF4-FFF2-40B4-BE49-F238E27FC236}">
-                <a16:creationId xmlns:a16="http://schemas.microsoft.com/office/drawing/2014/main" id="{A4FD10E4-0D15-BD1D-B050-F3587FF37177}"/>
+                <a16:creationId xmlns:a16="http://schemas.microsoft.com/office/drawing/2014/main" id="{0D3BC690-2827-5ED7-2524-99B3119C61EC}"/>
               </a:ext>
             </a:extLst>
           </p:cNvPr>
@@ -3417,7 +3419,7 @@
           <p:cNvPr id="3" name="Rectangle 2">
             <a:extLst>
               <a:ext uri="{FF2B5EF4-FFF2-40B4-BE49-F238E27FC236}">
-                <a16:creationId xmlns:a16="http://schemas.microsoft.com/office/drawing/2014/main" id="{5DFCA6D3-B96F-88C0-4CB9-D31377A38BB2}"/>
+                <a16:creationId xmlns:a16="http://schemas.microsoft.com/office/drawing/2014/main" id="{EB066840-94AE-7D75-98B8-6612167B126F}"/>
               </a:ext>
             </a:extLst>
           </p:cNvPr>
@@ -3485,7 +3487,7 @@
           <p:cNvPr id="4" name="Rectangle: Rounded Corners 3">
             <a:extLst>
               <a:ext uri="{FF2B5EF4-FFF2-40B4-BE49-F238E27FC236}">
-                <a16:creationId xmlns:a16="http://schemas.microsoft.com/office/drawing/2014/main" id="{DB0EF888-25EB-BF2E-989F-E802B885112D}"/>
+                <a16:creationId xmlns:a16="http://schemas.microsoft.com/office/drawing/2014/main" id="{6355F4B9-FB65-372A-A694-3CA02029A896}"/>
               </a:ext>
             </a:extLst>
           </p:cNvPr>
@@ -3547,7 +3549,7 @@
           <p:cNvPr id="5" name="TextBox 4">
             <a:extLst>
               <a:ext uri="{FF2B5EF4-FFF2-40B4-BE49-F238E27FC236}">
-                <a16:creationId xmlns:a16="http://schemas.microsoft.com/office/drawing/2014/main" id="{5D738D51-BF4E-ADE2-7059-5AC8B2B1E4D6}"/>
+                <a16:creationId xmlns:a16="http://schemas.microsoft.com/office/drawing/2014/main" id="{674CFEEB-5331-A026-5C7B-68D7D01D62DB}"/>
               </a:ext>
             </a:extLst>
           </p:cNvPr>
@@ -3587,7 +3589,7 @@
           <p:cNvPr id="6" name="TextBox 5">
             <a:extLst>
               <a:ext uri="{FF2B5EF4-FFF2-40B4-BE49-F238E27FC236}">
-                <a16:creationId xmlns:a16="http://schemas.microsoft.com/office/drawing/2014/main" id="{0B04892D-AA8C-A34A-2820-197FD5FA22B7}"/>
+                <a16:creationId xmlns:a16="http://schemas.microsoft.com/office/drawing/2014/main" id="{BBFD618B-D986-6063-C634-41A78A035F26}"/>
               </a:ext>
             </a:extLst>
           </p:cNvPr>
@@ -3633,7 +3635,7 @@
           <p:cNvPr id="7" name="Rectangle: Rounded Corners 6">
             <a:extLst>
               <a:ext uri="{FF2B5EF4-FFF2-40B4-BE49-F238E27FC236}">
-                <a16:creationId xmlns:a16="http://schemas.microsoft.com/office/drawing/2014/main" id="{8A206D7B-1780-07F5-3939-3D94587034B5}"/>
+                <a16:creationId xmlns:a16="http://schemas.microsoft.com/office/drawing/2014/main" id="{2AD40383-7856-9272-008E-3E1CA604678F}"/>
               </a:ext>
             </a:extLst>
           </p:cNvPr>
@@ -3687,7 +3689,7 @@
           <p:cNvPr id="8" name="TextBox 7">
             <a:extLst>
               <a:ext uri="{FF2B5EF4-FFF2-40B4-BE49-F238E27FC236}">
-                <a16:creationId xmlns:a16="http://schemas.microsoft.com/office/drawing/2014/main" id="{BA6A026D-7852-D5DF-7B5B-4F94B34E19B8}"/>
+                <a16:creationId xmlns:a16="http://schemas.microsoft.com/office/drawing/2014/main" id="{221EDB04-FBB3-27C6-AE21-66F4CF83606A}"/>
               </a:ext>
             </a:extLst>
           </p:cNvPr>
@@ -3727,7 +3729,7 @@
           <p:cNvPr id="9" name="TextBox 8">
             <a:extLst>
               <a:ext uri="{FF2B5EF4-FFF2-40B4-BE49-F238E27FC236}">
-                <a16:creationId xmlns:a16="http://schemas.microsoft.com/office/drawing/2014/main" id="{BAC85F4C-97AF-D32D-5036-699F14432786}"/>
+                <a16:creationId xmlns:a16="http://schemas.microsoft.com/office/drawing/2014/main" id="{F704E137-2872-88B7-B7C3-5AB8623C56B1}"/>
               </a:ext>
             </a:extLst>
           </p:cNvPr>
@@ -3767,7 +3769,7 @@
           <p:cNvPr id="10" name="TextBox 9">
             <a:extLst>
               <a:ext uri="{FF2B5EF4-FFF2-40B4-BE49-F238E27FC236}">
-                <a16:creationId xmlns:a16="http://schemas.microsoft.com/office/drawing/2014/main" id="{66BAAF7A-35D9-1E0B-4BFA-3A60ED152C1E}"/>
+                <a16:creationId xmlns:a16="http://schemas.microsoft.com/office/drawing/2014/main" id="{96EAF3C5-C89A-0D54-D99A-10259A6FBB53}"/>
               </a:ext>
             </a:extLst>
           </p:cNvPr>
@@ -3807,7 +3809,7 @@
           <p:cNvPr id="11" name="TextBox 10">
             <a:extLst>
               <a:ext uri="{FF2B5EF4-FFF2-40B4-BE49-F238E27FC236}">
-                <a16:creationId xmlns:a16="http://schemas.microsoft.com/office/drawing/2014/main" id="{40E54E8F-8470-FD83-C072-6D92DED30BF5}"/>
+                <a16:creationId xmlns:a16="http://schemas.microsoft.com/office/drawing/2014/main" id="{7A5DD244-85AE-0322-C18C-938D4B4A7381}"/>
               </a:ext>
             </a:extLst>
           </p:cNvPr>
@@ -3853,7 +3855,7 @@
           <p:cNvPr id="12" name="Rectangle: Rounded Corners 11">
             <a:extLst>
               <a:ext uri="{FF2B5EF4-FFF2-40B4-BE49-F238E27FC236}">
-                <a16:creationId xmlns:a16="http://schemas.microsoft.com/office/drawing/2014/main" id="{3C37C163-F71B-E9CF-453B-B5954C2174B6}"/>
+                <a16:creationId xmlns:a16="http://schemas.microsoft.com/office/drawing/2014/main" id="{ED01B50C-B3F6-527B-7492-3D015862F821}"/>
               </a:ext>
             </a:extLst>
           </p:cNvPr>
@@ -3907,7 +3909,7 @@
           <p:cNvPr id="13" name="TextBox 12">
             <a:extLst>
               <a:ext uri="{FF2B5EF4-FFF2-40B4-BE49-F238E27FC236}">
-                <a16:creationId xmlns:a16="http://schemas.microsoft.com/office/drawing/2014/main" id="{557ECD73-D6DA-4148-9F05-903338DEF22A}"/>
+                <a16:creationId xmlns:a16="http://schemas.microsoft.com/office/drawing/2014/main" id="{83AFB9D1-EED5-7FEC-ABEC-373D45E40AFF}"/>
               </a:ext>
             </a:extLst>
           </p:cNvPr>
@@ -3947,7 +3949,7 @@
           <p:cNvPr id="14" name="TextBox 13">
             <a:extLst>
               <a:ext uri="{FF2B5EF4-FFF2-40B4-BE49-F238E27FC236}">
-                <a16:creationId xmlns:a16="http://schemas.microsoft.com/office/drawing/2014/main" id="{F80BF6F3-78C8-F784-7ABB-8C4F82B1464B}"/>
+                <a16:creationId xmlns:a16="http://schemas.microsoft.com/office/drawing/2014/main" id="{07FFF95F-BFFB-2615-2F92-CF9F9C7D5296}"/>
               </a:ext>
             </a:extLst>
           </p:cNvPr>
@@ -3995,7 +3997,7 @@
     </p:spTree>
     <p:extLst>
       <p:ext uri="{BB962C8B-B14F-4D97-AF65-F5344CB8AC3E}">
-        <p14:creationId xmlns:p14="http://schemas.microsoft.com/office/powerpoint/2010/main" val="302574399"/>
+        <p14:creationId xmlns:p14="http://schemas.microsoft.com/office/powerpoint/2010/main" val="2305339078"/>
       </p:ext>
     </p:extLst>
   </p:cSld>
@@ -4027,7 +4029,7 @@
           <p:cNvPr id="2" name="Rectangle 1">
             <a:extLst>
               <a:ext uri="{FF2B5EF4-FFF2-40B4-BE49-F238E27FC236}">
-                <a16:creationId xmlns:a16="http://schemas.microsoft.com/office/drawing/2014/main" id="{F76D2417-A0EA-AA50-D8A2-3B233C5545FC}"/>
+                <a16:creationId xmlns:a16="http://schemas.microsoft.com/office/drawing/2014/main" id="{F3EE8F96-3808-2162-EA59-1D84A8C27F0D}"/>
               </a:ext>
             </a:extLst>
           </p:cNvPr>
@@ -4095,7 +4097,7 @@
           <p:cNvPr id="3" name="Rectangle 2">
             <a:extLst>
               <a:ext uri="{FF2B5EF4-FFF2-40B4-BE49-F238E27FC236}">
-                <a16:creationId xmlns:a16="http://schemas.microsoft.com/office/drawing/2014/main" id="{6758F1CB-B424-B49B-F376-082BA4C37463}"/>
+                <a16:creationId xmlns:a16="http://schemas.microsoft.com/office/drawing/2014/main" id="{D69AADAF-B798-90CE-1F4C-E8F50C7A1A96}"/>
               </a:ext>
             </a:extLst>
           </p:cNvPr>
@@ -4163,7 +4165,7 @@
           <p:cNvPr id="4" name="Rectangle: Rounded Corners 3">
             <a:extLst>
               <a:ext uri="{FF2B5EF4-FFF2-40B4-BE49-F238E27FC236}">
-                <a16:creationId xmlns:a16="http://schemas.microsoft.com/office/drawing/2014/main" id="{DE576480-60CA-BE21-F38E-A914BBF37022}"/>
+                <a16:creationId xmlns:a16="http://schemas.microsoft.com/office/drawing/2014/main" id="{DA0CDB4A-33CD-7B43-2FAA-199641186C21}"/>
               </a:ext>
             </a:extLst>
           </p:cNvPr>
@@ -4225,7 +4227,7 @@
           <p:cNvPr id="5" name="TextBox 4">
             <a:extLst>
               <a:ext uri="{FF2B5EF4-FFF2-40B4-BE49-F238E27FC236}">
-                <a16:creationId xmlns:a16="http://schemas.microsoft.com/office/drawing/2014/main" id="{97E365D0-4568-3811-15DE-88D8BFADC898}"/>
+                <a16:creationId xmlns:a16="http://schemas.microsoft.com/office/drawing/2014/main" id="{5D9AEECF-8B4B-6FFC-A774-920623369C1B}"/>
               </a:ext>
             </a:extLst>
           </p:cNvPr>
@@ -4271,7 +4273,7 @@
           <p:cNvPr id="6" name="Rectangle: Rounded Corners 5">
             <a:extLst>
               <a:ext uri="{FF2B5EF4-FFF2-40B4-BE49-F238E27FC236}">
-                <a16:creationId xmlns:a16="http://schemas.microsoft.com/office/drawing/2014/main" id="{9E90FE96-6194-8CC6-6FF6-A7E6E8C10948}"/>
+                <a16:creationId xmlns:a16="http://schemas.microsoft.com/office/drawing/2014/main" id="{E0B748FB-434F-13C5-772E-BE71E8E05338}"/>
               </a:ext>
             </a:extLst>
           </p:cNvPr>
@@ -4325,7 +4327,7 @@
           <p:cNvPr id="7" name="TextBox 6">
             <a:extLst>
               <a:ext uri="{FF2B5EF4-FFF2-40B4-BE49-F238E27FC236}">
-                <a16:creationId xmlns:a16="http://schemas.microsoft.com/office/drawing/2014/main" id="{D2F74531-02DE-5F81-1EE7-30C99654051D}"/>
+                <a16:creationId xmlns:a16="http://schemas.microsoft.com/office/drawing/2014/main" id="{FC66AD23-0C68-2D8F-C242-7C571426BE44}"/>
               </a:ext>
             </a:extLst>
           </p:cNvPr>
@@ -4365,7 +4367,7 @@
           <p:cNvPr id="8" name="TextBox 7">
             <a:extLst>
               <a:ext uri="{FF2B5EF4-FFF2-40B4-BE49-F238E27FC236}">
-                <a16:creationId xmlns:a16="http://schemas.microsoft.com/office/drawing/2014/main" id="{BAAC67B4-C083-2309-E2E0-45B9EF724F50}"/>
+                <a16:creationId xmlns:a16="http://schemas.microsoft.com/office/drawing/2014/main" id="{28754E48-F5E8-0B82-01E3-859E2F2828F6}"/>
               </a:ext>
             </a:extLst>
           </p:cNvPr>
@@ -4412,7 +4414,7 @@
           <p:cNvPr id="9" name="Rectangle: Rounded Corners 8">
             <a:extLst>
               <a:ext uri="{FF2B5EF4-FFF2-40B4-BE49-F238E27FC236}">
-                <a16:creationId xmlns:a16="http://schemas.microsoft.com/office/drawing/2014/main" id="{4D9AA954-5302-87D5-A030-A99C6B409211}"/>
+                <a16:creationId xmlns:a16="http://schemas.microsoft.com/office/drawing/2014/main" id="{35890CB0-9D8D-3543-C773-603050BA4E68}"/>
               </a:ext>
             </a:extLst>
           </p:cNvPr>
@@ -4466,7 +4468,7 @@
           <p:cNvPr id="10" name="TextBox 9">
             <a:extLst>
               <a:ext uri="{FF2B5EF4-FFF2-40B4-BE49-F238E27FC236}">
-                <a16:creationId xmlns:a16="http://schemas.microsoft.com/office/drawing/2014/main" id="{E5F5CB2F-614B-AC7C-6523-22CB82FCDE7D}"/>
+                <a16:creationId xmlns:a16="http://schemas.microsoft.com/office/drawing/2014/main" id="{B8B64157-6275-E546-D5C4-2715560A6F50}"/>
               </a:ext>
             </a:extLst>
           </p:cNvPr>
@@ -4506,7 +4508,7 @@
           <p:cNvPr id="11" name="TextBox 10">
             <a:extLst>
               <a:ext uri="{FF2B5EF4-FFF2-40B4-BE49-F238E27FC236}">
-                <a16:creationId xmlns:a16="http://schemas.microsoft.com/office/drawing/2014/main" id="{FEA379FD-F7C5-376A-0864-BADFA4D08718}"/>
+                <a16:creationId xmlns:a16="http://schemas.microsoft.com/office/drawing/2014/main" id="{0B62ED57-E715-333F-6DCA-896341358333}"/>
               </a:ext>
             </a:extLst>
           </p:cNvPr>
@@ -4553,7 +4555,7 @@
           <p:cNvPr id="12" name="Rectangle: Rounded Corners 11">
             <a:extLst>
               <a:ext uri="{FF2B5EF4-FFF2-40B4-BE49-F238E27FC236}">
-                <a16:creationId xmlns:a16="http://schemas.microsoft.com/office/drawing/2014/main" id="{ED8CA0D2-42B0-3BFE-55BC-3A922BD922CD}"/>
+                <a16:creationId xmlns:a16="http://schemas.microsoft.com/office/drawing/2014/main" id="{32C3DD30-7327-36E5-AD36-D38DB620E59A}"/>
               </a:ext>
             </a:extLst>
           </p:cNvPr>
@@ -4607,7 +4609,7 @@
           <p:cNvPr id="13" name="TextBox 12">
             <a:extLst>
               <a:ext uri="{FF2B5EF4-FFF2-40B4-BE49-F238E27FC236}">
-                <a16:creationId xmlns:a16="http://schemas.microsoft.com/office/drawing/2014/main" id="{715F029A-66FD-873A-DBC1-23B98440D22F}"/>
+                <a16:creationId xmlns:a16="http://schemas.microsoft.com/office/drawing/2014/main" id="{6F8392A9-EC83-A5A6-FD08-8133D4197B17}"/>
               </a:ext>
             </a:extLst>
           </p:cNvPr>
@@ -4653,7 +4655,7 @@
           <p:cNvPr id="14" name="TextBox 13">
             <a:extLst>
               <a:ext uri="{FF2B5EF4-FFF2-40B4-BE49-F238E27FC236}">
-                <a16:creationId xmlns:a16="http://schemas.microsoft.com/office/drawing/2014/main" id="{ED7490BE-7182-CAFD-FDB2-ED711E806FB1}"/>
+                <a16:creationId xmlns:a16="http://schemas.microsoft.com/office/drawing/2014/main" id="{C512B20A-4110-32BC-E7B3-C0C0EAD568D7}"/>
               </a:ext>
             </a:extLst>
           </p:cNvPr>
@@ -4700,7 +4702,7 @@
           <p:cNvPr id="15" name="Rectangle: Rounded Corners 14">
             <a:extLst>
               <a:ext uri="{FF2B5EF4-FFF2-40B4-BE49-F238E27FC236}">
-                <a16:creationId xmlns:a16="http://schemas.microsoft.com/office/drawing/2014/main" id="{FC1E8495-3622-F099-2DC8-F19B306D8238}"/>
+                <a16:creationId xmlns:a16="http://schemas.microsoft.com/office/drawing/2014/main" id="{FC6C2F52-8A92-F55C-6E1F-BAC47E4B0E35}"/>
               </a:ext>
             </a:extLst>
           </p:cNvPr>
@@ -4754,7 +4756,7 @@
           <p:cNvPr id="16" name="TextBox 15">
             <a:extLst>
               <a:ext uri="{FF2B5EF4-FFF2-40B4-BE49-F238E27FC236}">
-                <a16:creationId xmlns:a16="http://schemas.microsoft.com/office/drawing/2014/main" id="{52030800-BFC7-8259-BBC5-D5FA49B68E90}"/>
+                <a16:creationId xmlns:a16="http://schemas.microsoft.com/office/drawing/2014/main" id="{ED696B88-B8EE-DF97-66A6-861323BA7736}"/>
               </a:ext>
             </a:extLst>
           </p:cNvPr>
@@ -4800,7 +4802,7 @@
           <p:cNvPr id="17" name="TextBox 16">
             <a:extLst>
               <a:ext uri="{FF2B5EF4-FFF2-40B4-BE49-F238E27FC236}">
-                <a16:creationId xmlns:a16="http://schemas.microsoft.com/office/drawing/2014/main" id="{1A010E24-1B44-ADCB-1F76-9F3FCA920DC2}"/>
+                <a16:creationId xmlns:a16="http://schemas.microsoft.com/office/drawing/2014/main" id="{DFA12737-D94F-1B47-9DAE-66A9098E26A3}"/>
               </a:ext>
             </a:extLst>
           </p:cNvPr>
@@ -4847,7 +4849,7 @@
           <p:cNvPr id="18" name="Rectangle: Rounded Corners 17">
             <a:extLst>
               <a:ext uri="{FF2B5EF4-FFF2-40B4-BE49-F238E27FC236}">
-                <a16:creationId xmlns:a16="http://schemas.microsoft.com/office/drawing/2014/main" id="{220CD408-C7FC-EA25-A50A-5275678D2450}"/>
+                <a16:creationId xmlns:a16="http://schemas.microsoft.com/office/drawing/2014/main" id="{FAF66E4A-71E5-85F9-6F3D-CEBFA4E0EFC1}"/>
               </a:ext>
             </a:extLst>
           </p:cNvPr>
@@ -4901,7 +4903,7 @@
           <p:cNvPr id="19" name="TextBox 18">
             <a:extLst>
               <a:ext uri="{FF2B5EF4-FFF2-40B4-BE49-F238E27FC236}">
-                <a16:creationId xmlns:a16="http://schemas.microsoft.com/office/drawing/2014/main" id="{3A7C2CAF-C779-B60E-C46E-06DCF2E7E33F}"/>
+                <a16:creationId xmlns:a16="http://schemas.microsoft.com/office/drawing/2014/main" id="{E7ACB80D-B14D-6491-26C4-B9D984D3F972}"/>
               </a:ext>
             </a:extLst>
           </p:cNvPr>
@@ -4939,7 +4941,7 @@
     </p:spTree>
     <p:extLst>
       <p:ext uri="{BB962C8B-B14F-4D97-AF65-F5344CB8AC3E}">
-        <p14:creationId xmlns:p14="http://schemas.microsoft.com/office/powerpoint/2010/main" val="3564788391"/>
+        <p14:creationId xmlns:p14="http://schemas.microsoft.com/office/powerpoint/2010/main" val="57208972"/>
       </p:ext>
     </p:extLst>
   </p:cSld>
@@ -4971,7 +4973,7 @@
           <p:cNvPr id="2" name="Rectangle 1">
             <a:extLst>
               <a:ext uri="{FF2B5EF4-FFF2-40B4-BE49-F238E27FC236}">
-                <a16:creationId xmlns:a16="http://schemas.microsoft.com/office/drawing/2014/main" id="{C4AB353A-2C41-EA2D-4044-6D141C5B6D2F}"/>
+                <a16:creationId xmlns:a16="http://schemas.microsoft.com/office/drawing/2014/main" id="{5C3C4598-3E4F-CBA6-E721-C4C3BFEA6EBF}"/>
               </a:ext>
             </a:extLst>
           </p:cNvPr>
@@ -5039,7 +5041,7 @@
           <p:cNvPr id="3" name="Rectangle 2">
             <a:extLst>
               <a:ext uri="{FF2B5EF4-FFF2-40B4-BE49-F238E27FC236}">
-                <a16:creationId xmlns:a16="http://schemas.microsoft.com/office/drawing/2014/main" id="{F6D0D67F-55DA-7DC1-15BD-002821B0B9ED}"/>
+                <a16:creationId xmlns:a16="http://schemas.microsoft.com/office/drawing/2014/main" id="{C25DAA43-85C8-9C21-408A-E610D3055966}"/>
               </a:ext>
             </a:extLst>
           </p:cNvPr>
@@ -5107,7 +5109,7 @@
           <p:cNvPr id="4" name="Rectangle: Rounded Corners 3">
             <a:extLst>
               <a:ext uri="{FF2B5EF4-FFF2-40B4-BE49-F238E27FC236}">
-                <a16:creationId xmlns:a16="http://schemas.microsoft.com/office/drawing/2014/main" id="{345703B3-325B-A3EB-6A01-7D1A118F23E0}"/>
+                <a16:creationId xmlns:a16="http://schemas.microsoft.com/office/drawing/2014/main" id="{1CFAFC93-A5DB-F8DA-E754-0742B396F952}"/>
               </a:ext>
             </a:extLst>
           </p:cNvPr>
@@ -5169,7 +5171,7 @@
           <p:cNvPr id="5" name="TextBox 4">
             <a:extLst>
               <a:ext uri="{FF2B5EF4-FFF2-40B4-BE49-F238E27FC236}">
-                <a16:creationId xmlns:a16="http://schemas.microsoft.com/office/drawing/2014/main" id="{B1459A80-E90A-668A-C8B0-67A958FD3196}"/>
+                <a16:creationId xmlns:a16="http://schemas.microsoft.com/office/drawing/2014/main" id="{53EA0169-F14D-9781-BBC0-28A5EEBA9F27}"/>
               </a:ext>
             </a:extLst>
           </p:cNvPr>
@@ -5215,7 +5217,7 @@
           <p:cNvPr id="6" name="Rectangle: Rounded Corners 5">
             <a:extLst>
               <a:ext uri="{FF2B5EF4-FFF2-40B4-BE49-F238E27FC236}">
-                <a16:creationId xmlns:a16="http://schemas.microsoft.com/office/drawing/2014/main" id="{CF68488A-3368-90EF-5AF3-6008593B1D68}"/>
+                <a16:creationId xmlns:a16="http://schemas.microsoft.com/office/drawing/2014/main" id="{C88DF921-3166-91B3-7F18-01C2F9088F5A}"/>
               </a:ext>
             </a:extLst>
           </p:cNvPr>
@@ -5269,7 +5271,7 @@
           <p:cNvPr id="7" name="TextBox 6">
             <a:extLst>
               <a:ext uri="{FF2B5EF4-FFF2-40B4-BE49-F238E27FC236}">
-                <a16:creationId xmlns:a16="http://schemas.microsoft.com/office/drawing/2014/main" id="{0E543A54-05D3-BD16-A274-8D0DB2BC1522}"/>
+                <a16:creationId xmlns:a16="http://schemas.microsoft.com/office/drawing/2014/main" id="{C081AD90-04E4-A353-E581-6A9E296CEEC8}"/>
               </a:ext>
             </a:extLst>
           </p:cNvPr>
@@ -5315,7 +5317,7 @@
           <p:cNvPr id="8" name="TextBox 7">
             <a:extLst>
               <a:ext uri="{FF2B5EF4-FFF2-40B4-BE49-F238E27FC236}">
-                <a16:creationId xmlns:a16="http://schemas.microsoft.com/office/drawing/2014/main" id="{726B39EE-A0F0-B485-0B2A-E2D52314FAED}"/>
+                <a16:creationId xmlns:a16="http://schemas.microsoft.com/office/drawing/2014/main" id="{30DE709C-C0C5-3C01-7B0C-EEED8F637A5D}"/>
               </a:ext>
             </a:extLst>
           </p:cNvPr>
@@ -5363,7 +5365,7 @@
           <p:cNvPr id="9" name="Rectangle: Rounded Corners 8">
             <a:extLst>
               <a:ext uri="{FF2B5EF4-FFF2-40B4-BE49-F238E27FC236}">
-                <a16:creationId xmlns:a16="http://schemas.microsoft.com/office/drawing/2014/main" id="{0969C97D-1F7D-2FC7-F74A-688FA6C88D1A}"/>
+                <a16:creationId xmlns:a16="http://schemas.microsoft.com/office/drawing/2014/main" id="{F0E4C997-E30C-54A9-9243-A43D2AAC9D17}"/>
               </a:ext>
             </a:extLst>
           </p:cNvPr>
@@ -5417,7 +5419,7 @@
           <p:cNvPr id="10" name="TextBox 9">
             <a:extLst>
               <a:ext uri="{FF2B5EF4-FFF2-40B4-BE49-F238E27FC236}">
-                <a16:creationId xmlns:a16="http://schemas.microsoft.com/office/drawing/2014/main" id="{B52399FF-337B-0966-79F3-26D1F7496442}"/>
+                <a16:creationId xmlns:a16="http://schemas.microsoft.com/office/drawing/2014/main" id="{004C59EC-E50F-72B4-2906-6E486257B671}"/>
               </a:ext>
             </a:extLst>
           </p:cNvPr>
@@ -5463,7 +5465,7 @@
           <p:cNvPr id="11" name="TextBox 10">
             <a:extLst>
               <a:ext uri="{FF2B5EF4-FFF2-40B4-BE49-F238E27FC236}">
-                <a16:creationId xmlns:a16="http://schemas.microsoft.com/office/drawing/2014/main" id="{011C7594-FB6E-687F-F9F4-531FB03A6E04}"/>
+                <a16:creationId xmlns:a16="http://schemas.microsoft.com/office/drawing/2014/main" id="{E6288182-8B11-BC06-6615-3DC37189CD23}"/>
               </a:ext>
             </a:extLst>
           </p:cNvPr>
@@ -5505,7 +5507,7 @@
           <p:cNvPr id="12" name="Rectangle: Rounded Corners 11">
             <a:extLst>
               <a:ext uri="{FF2B5EF4-FFF2-40B4-BE49-F238E27FC236}">
-                <a16:creationId xmlns:a16="http://schemas.microsoft.com/office/drawing/2014/main" id="{FEF72985-2565-AC8F-9AFF-E145D0B1B102}"/>
+                <a16:creationId xmlns:a16="http://schemas.microsoft.com/office/drawing/2014/main" id="{33A23691-91FC-1EB8-203A-C159110D2B4B}"/>
               </a:ext>
             </a:extLst>
           </p:cNvPr>
@@ -5559,7 +5561,7 @@
           <p:cNvPr id="13" name="TextBox 12">
             <a:extLst>
               <a:ext uri="{FF2B5EF4-FFF2-40B4-BE49-F238E27FC236}">
-                <a16:creationId xmlns:a16="http://schemas.microsoft.com/office/drawing/2014/main" id="{7127065B-F218-ED86-C83B-04E58E099EC1}"/>
+                <a16:creationId xmlns:a16="http://schemas.microsoft.com/office/drawing/2014/main" id="{E6AA8C0D-4CBA-AA0A-AC28-36C6611B744E}"/>
               </a:ext>
             </a:extLst>
           </p:cNvPr>
@@ -5605,7 +5607,7 @@
           <p:cNvPr id="14" name="TextBox 13">
             <a:extLst>
               <a:ext uri="{FF2B5EF4-FFF2-40B4-BE49-F238E27FC236}">
-                <a16:creationId xmlns:a16="http://schemas.microsoft.com/office/drawing/2014/main" id="{72037250-3D9D-062C-B2A1-3C1AD4A1320E}"/>
+                <a16:creationId xmlns:a16="http://schemas.microsoft.com/office/drawing/2014/main" id="{47FDE7BE-0FC2-6AF1-4756-CFFE05CB8247}"/>
               </a:ext>
             </a:extLst>
           </p:cNvPr>
@@ -5653,7 +5655,7 @@
           <p:cNvPr id="15" name="Rectangle: Rounded Corners 14">
             <a:extLst>
               <a:ext uri="{FF2B5EF4-FFF2-40B4-BE49-F238E27FC236}">
-                <a16:creationId xmlns:a16="http://schemas.microsoft.com/office/drawing/2014/main" id="{A4B51605-6271-ADAB-7D87-04251DAAA058}"/>
+                <a16:creationId xmlns:a16="http://schemas.microsoft.com/office/drawing/2014/main" id="{8052D1A0-2C89-129A-1A5D-14D6419F311B}"/>
               </a:ext>
             </a:extLst>
           </p:cNvPr>
@@ -5707,7 +5709,7 @@
           <p:cNvPr id="16" name="TextBox 15">
             <a:extLst>
               <a:ext uri="{FF2B5EF4-FFF2-40B4-BE49-F238E27FC236}">
-                <a16:creationId xmlns:a16="http://schemas.microsoft.com/office/drawing/2014/main" id="{45C25E25-DA4D-F741-B404-17B3EB489D0F}"/>
+                <a16:creationId xmlns:a16="http://schemas.microsoft.com/office/drawing/2014/main" id="{022A1FA4-B066-82F9-5BBC-577AF1FBD7D7}"/>
               </a:ext>
             </a:extLst>
           </p:cNvPr>
@@ -5747,7 +5749,7 @@
           <p:cNvPr id="17" name="TextBox 16">
             <a:extLst>
               <a:ext uri="{FF2B5EF4-FFF2-40B4-BE49-F238E27FC236}">
-                <a16:creationId xmlns:a16="http://schemas.microsoft.com/office/drawing/2014/main" id="{534F906F-ACEF-DAE3-75AA-8F0B74951519}"/>
+                <a16:creationId xmlns:a16="http://schemas.microsoft.com/office/drawing/2014/main" id="{92537674-45B8-22B9-34FC-59CCF3F58245}"/>
               </a:ext>
             </a:extLst>
           </p:cNvPr>
@@ -5795,7 +5797,7 @@
           <p:cNvPr id="18" name="Rectangle: Rounded Corners 17">
             <a:extLst>
               <a:ext uri="{FF2B5EF4-FFF2-40B4-BE49-F238E27FC236}">
-                <a16:creationId xmlns:a16="http://schemas.microsoft.com/office/drawing/2014/main" id="{3DDD5C42-C40C-B198-DC70-42669BF9DD60}"/>
+                <a16:creationId xmlns:a16="http://schemas.microsoft.com/office/drawing/2014/main" id="{7E8F890C-4B27-BD61-59CC-81E92D1AC0E7}"/>
               </a:ext>
             </a:extLst>
           </p:cNvPr>
@@ -5849,7 +5851,7 @@
           <p:cNvPr id="19" name="TextBox 18">
             <a:extLst>
               <a:ext uri="{FF2B5EF4-FFF2-40B4-BE49-F238E27FC236}">
-                <a16:creationId xmlns:a16="http://schemas.microsoft.com/office/drawing/2014/main" id="{C2B5834C-4E19-351C-353D-67744A7A4E72}"/>
+                <a16:creationId xmlns:a16="http://schemas.microsoft.com/office/drawing/2014/main" id="{2097C520-1608-F68B-507D-21225474D6D7}"/>
               </a:ext>
             </a:extLst>
           </p:cNvPr>
@@ -5895,7 +5897,7 @@
           <p:cNvPr id="20" name="TextBox 19">
             <a:extLst>
               <a:ext uri="{FF2B5EF4-FFF2-40B4-BE49-F238E27FC236}">
-                <a16:creationId xmlns:a16="http://schemas.microsoft.com/office/drawing/2014/main" id="{3FC58045-160B-2F25-9F05-BB22CF73AA5F}"/>
+                <a16:creationId xmlns:a16="http://schemas.microsoft.com/office/drawing/2014/main" id="{BE92ADA5-9DFF-F096-D930-294A78CF3B32}"/>
               </a:ext>
             </a:extLst>
           </p:cNvPr>
@@ -5926,7 +5928,7 @@
                 <a:latin typeface="Segoe UI" panose="020B0502040204020203" pitchFamily="34" charset="0"/>
               </a:rPr>
               <a:t>•  Multi-hop transmission loss model: Delivered Power = Surplus x Product(1 - loss_i) for k hops.
-•  Greedy shortest-distance P2P settlement ledger calculating sent kW, line losses, and financial bill savings.
+•  Greedy shortest-distance P2P settlement ledger calculating sent kW, line losses, and financial bill savings in INR (Rs).
 •  1-Click Executive Summary Report export (CSV/PDF) containing microgrid KPIs and transaction records.
 •  4 Pre-built realistic microgrid presets localized to Nerul, Navi Mumbai (Suburban, Hillside, Islands, Custom).</a:t>
             </a:r>
@@ -5936,7 +5938,1303 @@
     </p:spTree>
     <p:extLst>
       <p:ext uri="{BB962C8B-B14F-4D97-AF65-F5344CB8AC3E}">
-        <p14:creationId xmlns:p14="http://schemas.microsoft.com/office/powerpoint/2010/main" val="3789079828"/>
+        <p14:creationId xmlns:p14="http://schemas.microsoft.com/office/powerpoint/2010/main" val="515759779"/>
+      </p:ext>
+    </p:extLst>
+  </p:cSld>
+  <p:clrMapOvr>
+    <a:masterClrMapping/>
+  </p:clrMapOvr>
+</p:sld>
+</file>
+
+<file path=ppt/slides/slide4.xml><?xml version="1.0" encoding="utf-8"?>
+<p:sld xmlns:a="http://schemas.openxmlformats.org/drawingml/2006/main" xmlns:r="http://schemas.openxmlformats.org/officeDocument/2006/relationships" xmlns:p="http://schemas.openxmlformats.org/presentationml/2006/main">
+  <p:cSld>
+    <p:spTree>
+      <p:nvGrpSpPr>
+        <p:cNvPr id="1" name=""/>
+        <p:cNvGrpSpPr/>
+        <p:nvPr/>
+      </p:nvGrpSpPr>
+      <p:grpSpPr>
+        <a:xfrm>
+          <a:off x="0" y="0"/>
+          <a:ext cx="0" cy="0"/>
+          <a:chOff x="0" y="0"/>
+          <a:chExt cx="0" cy="0"/>
+        </a:xfrm>
+      </p:grpSpPr>
+      <p:sp>
+        <p:nvSpPr>
+          <p:cNvPr id="2" name="Rectangle 1">
+            <a:extLst>
+              <a:ext uri="{FF2B5EF4-FFF2-40B4-BE49-F238E27FC236}">
+                <a16:creationId xmlns:a16="http://schemas.microsoft.com/office/drawing/2014/main" id="{2ADA0FC6-48A3-DEBF-EECA-CF29DD18C161}"/>
+              </a:ext>
+            </a:extLst>
+          </p:cNvPr>
+          <p:cNvSpPr/>
+          <p:nvPr/>
+        </p:nvSpPr>
+        <p:spPr>
+          <a:xfrm>
+            <a:off x="0" y="0"/>
+            <a:ext cx="12192000" cy="6858000"/>
+          </a:xfrm>
+          <a:prstGeom prst="rect">
+            <a:avLst/>
+          </a:prstGeom>
+          <a:solidFill>
+            <a:srgbClr val="0B1120"/>
+          </a:solidFill>
+          <a:ln w="12700" cap="flat" cmpd="sng" algn="ctr">
+            <a:noFill/>
+            <a:prstDash val="solid"/>
+            <a:miter lim="800000"/>
+          </a:ln>
+          <a:effectLst/>
+          <a:extLst>
+            <a:ext uri="{91240B29-F687-4F45-9708-019B960494DF}">
+              <a14:hiddenLine xmlns:a14="http://schemas.microsoft.com/office/drawing/2010/main" w="12700" cap="flat" cmpd="sng" algn="ctr">
+                <a:solidFill>
+                  <a:schemeClr val="accent1">
+                    <a:shade val="15000"/>
+                  </a:schemeClr>
+                </a:solidFill>
+                <a:prstDash val="solid"/>
+                <a:miter lim="800000"/>
+              </a14:hiddenLine>
+            </a:ext>
+          </a:extLst>
+        </p:spPr>
+        <p:style>
+          <a:lnRef idx="2">
+            <a:schemeClr val="accent1">
+              <a:shade val="15000"/>
+            </a:schemeClr>
+          </a:lnRef>
+          <a:fillRef idx="1">
+            <a:schemeClr val="accent1"/>
+          </a:fillRef>
+          <a:effectRef idx="0">
+            <a:schemeClr val="accent1"/>
+          </a:effectRef>
+          <a:fontRef idx="minor">
+            <a:schemeClr val="lt1"/>
+          </a:fontRef>
+        </p:style>
+        <p:txBody>
+          <a:bodyPr rtlCol="0" anchor="ctr"/>
+          <a:lstStyle/>
+          <a:p>
+            <a:pPr algn="ctr"/>
+            <a:endParaRPr lang="en-IN"/>
+          </a:p>
+        </p:txBody>
+      </p:sp>
+      <p:sp>
+        <p:nvSpPr>
+          <p:cNvPr id="3" name="Rectangle 2">
+            <a:extLst>
+              <a:ext uri="{FF2B5EF4-FFF2-40B4-BE49-F238E27FC236}">
+                <a16:creationId xmlns:a16="http://schemas.microsoft.com/office/drawing/2014/main" id="{E9A58D3F-7805-CC2E-1701-33046F37296D}"/>
+              </a:ext>
+            </a:extLst>
+          </p:cNvPr>
+          <p:cNvSpPr/>
+          <p:nvPr/>
+        </p:nvSpPr>
+        <p:spPr>
+          <a:xfrm>
+            <a:off x="0" y="0"/>
+            <a:ext cx="12192000" cy="76200"/>
+          </a:xfrm>
+          <a:prstGeom prst="rect">
+            <a:avLst/>
+          </a:prstGeom>
+          <a:solidFill>
+            <a:srgbClr val="F59E0B"/>
+          </a:solidFill>
+          <a:ln w="12700" cap="flat" cmpd="sng" algn="ctr">
+            <a:noFill/>
+            <a:prstDash val="solid"/>
+            <a:miter lim="800000"/>
+          </a:ln>
+          <a:effectLst/>
+          <a:extLst>
+            <a:ext uri="{91240B29-F687-4F45-9708-019B960494DF}">
+              <a14:hiddenLine xmlns:a14="http://schemas.microsoft.com/office/drawing/2010/main" w="12700" cap="flat" cmpd="sng" algn="ctr">
+                <a:solidFill>
+                  <a:schemeClr val="accent1">
+                    <a:shade val="15000"/>
+                  </a:schemeClr>
+                </a:solidFill>
+                <a:prstDash val="solid"/>
+                <a:miter lim="800000"/>
+              </a14:hiddenLine>
+            </a:ext>
+          </a:extLst>
+        </p:spPr>
+        <p:style>
+          <a:lnRef idx="2">
+            <a:schemeClr val="accent1">
+              <a:shade val="15000"/>
+            </a:schemeClr>
+          </a:lnRef>
+          <a:fillRef idx="1">
+            <a:schemeClr val="accent1"/>
+          </a:fillRef>
+          <a:effectRef idx="0">
+            <a:schemeClr val="accent1"/>
+          </a:effectRef>
+          <a:fontRef idx="minor">
+            <a:schemeClr val="lt1"/>
+          </a:fontRef>
+        </p:style>
+        <p:txBody>
+          <a:bodyPr rtlCol="0" anchor="ctr"/>
+          <a:lstStyle/>
+          <a:p>
+            <a:pPr algn="ctr"/>
+            <a:endParaRPr lang="en-IN"/>
+          </a:p>
+        </p:txBody>
+      </p:sp>
+      <p:sp>
+        <p:nvSpPr>
+          <p:cNvPr id="4" name="Rectangle: Rounded Corners 3">
+            <a:extLst>
+              <a:ext uri="{FF2B5EF4-FFF2-40B4-BE49-F238E27FC236}">
+                <a16:creationId xmlns:a16="http://schemas.microsoft.com/office/drawing/2014/main" id="{7D42904E-1739-50AE-D182-B750B1F081D0}"/>
+              </a:ext>
+            </a:extLst>
+          </p:cNvPr>
+          <p:cNvSpPr/>
+          <p:nvPr/>
+        </p:nvSpPr>
+        <p:spPr>
+          <a:xfrm>
+            <a:off x="635000" y="279400"/>
+            <a:ext cx="3302000" cy="330200"/>
+          </a:xfrm>
+          <a:prstGeom prst="roundRect">
+            <a:avLst/>
+          </a:prstGeom>
+          <a:solidFill>
+            <a:srgbClr val="1A2639"/>
+          </a:solidFill>
+          <a:ln w="15240">
+            <a:solidFill>
+              <a:srgbClr val="F59E0B"/>
+            </a:solidFill>
+          </a:ln>
+        </p:spPr>
+        <p:style>
+          <a:lnRef idx="2">
+            <a:schemeClr val="accent1">
+              <a:shade val="15000"/>
+            </a:schemeClr>
+          </a:lnRef>
+          <a:fillRef idx="1">
+            <a:schemeClr val="accent1"/>
+          </a:fillRef>
+          <a:effectRef idx="0">
+            <a:schemeClr val="accent1"/>
+          </a:effectRef>
+          <a:fontRef idx="minor">
+            <a:schemeClr val="lt1"/>
+          </a:fontRef>
+        </p:style>
+        <p:txBody>
+          <a:bodyPr rtlCol="0" anchor="ctr"/>
+          <a:lstStyle/>
+          <a:p>
+            <a:pPr algn="ctr"/>
+            <a:r>
+              <a:rPr lang="en-IN" sz="1000" b="1">
+                <a:solidFill>
+                  <a:srgbClr val="F59E0B"/>
+                </a:solidFill>
+                <a:latin typeface="Segoe UI" panose="020B0502040204020203" pitchFamily="34" charset="0"/>
+              </a:rPr>
+              <a:t>LIVE DEMO • TOPOLOGY &amp; CLOSURE</a:t>
+            </a:r>
+          </a:p>
+        </p:txBody>
+      </p:sp>
+      <p:sp>
+        <p:nvSpPr>
+          <p:cNvPr id="5" name="TextBox 4">
+            <a:extLst>
+              <a:ext uri="{FF2B5EF4-FFF2-40B4-BE49-F238E27FC236}">
+                <a16:creationId xmlns:a16="http://schemas.microsoft.com/office/drawing/2014/main" id="{424FB7B1-1041-F5D9-E75F-8C32C1DA405E}"/>
+              </a:ext>
+            </a:extLst>
+          </p:cNvPr>
+          <p:cNvSpPr txBox="1"/>
+          <p:nvPr/>
+        </p:nvSpPr>
+        <p:spPr>
+          <a:xfrm>
+            <a:off x="635000" y="635000"/>
+            <a:ext cx="10922000" cy="446276"/>
+          </a:xfrm>
+          <a:prstGeom prst="rect">
+            <a:avLst/>
+          </a:prstGeom>
+          <a:noFill/>
+        </p:spPr>
+        <p:txBody>
+          <a:bodyPr vert="horz" rtlCol="0">
+            <a:spAutoFit/>
+          </a:bodyPr>
+          <a:lstStyle/>
+          <a:p>
+            <a:r>
+              <a:rPr lang="en-US" sz="2300" b="1">
+                <a:solidFill>
+                  <a:srgbClr val="FFFFFF"/>
+                </a:solidFill>
+                <a:latin typeface="Segoe UI" panose="020B0502040204020203" pitchFamily="34" charset="0"/>
+              </a:rPr>
+              <a:t>Interactive Digraph Topology &amp; Warshall Reachability Matrix</a:t>
+            </a:r>
+            <a:endParaRPr lang="en-IN" sz="2300" b="1">
+              <a:solidFill>
+                <a:srgbClr val="FFFFFF"/>
+              </a:solidFill>
+              <a:latin typeface="Segoe UI" panose="020B0502040204020203" pitchFamily="34" charset="0"/>
+            </a:endParaRPr>
+          </a:p>
+        </p:txBody>
+      </p:sp>
+      <p:pic>
+        <p:nvPicPr>
+          <p:cNvPr id="7" name="Picture 6">
+            <a:extLst>
+              <a:ext uri="{FF2B5EF4-FFF2-40B4-BE49-F238E27FC236}">
+                <a16:creationId xmlns:a16="http://schemas.microsoft.com/office/drawing/2014/main" id="{4E57E79E-CBA2-A9B0-8184-E33327753749}"/>
+              </a:ext>
+            </a:extLst>
+          </p:cNvPr>
+          <p:cNvPicPr>
+            <a:picLocks/>
+          </p:cNvPicPr>
+          <p:nvPr/>
+        </p:nvPicPr>
+        <p:blipFill>
+          <a:blip r:embed="rId2">
+            <a:extLst>
+              <a:ext uri="{28A0092B-C50C-407E-A947-70E740481C1C}">
+                <a14:useLocalDpi xmlns:a14="http://schemas.microsoft.com/office/drawing/2010/main" val="0"/>
+              </a:ext>
+            </a:extLst>
+          </a:blip>
+          <a:stretch>
+            <a:fillRect/>
+          </a:stretch>
+        </p:blipFill>
+        <p:spPr>
+          <a:xfrm>
+            <a:off x="635000" y="1206500"/>
+            <a:ext cx="5270500" cy="3365500"/>
+          </a:xfrm>
+          <a:prstGeom prst="rect">
+            <a:avLst/>
+          </a:prstGeom>
+          <a:ln w="19050">
+            <a:solidFill>
+              <a:schemeClr val="tx1"/>
+            </a:solidFill>
+          </a:ln>
+        </p:spPr>
+      </p:pic>
+      <p:sp>
+        <p:nvSpPr>
+          <p:cNvPr id="8" name="Rectangle: Rounded Corners 7">
+            <a:extLst>
+              <a:ext uri="{FF2B5EF4-FFF2-40B4-BE49-F238E27FC236}">
+                <a16:creationId xmlns:a16="http://schemas.microsoft.com/office/drawing/2014/main" id="{9D0E3D99-245A-7706-7988-79FF3E61E1E5}"/>
+              </a:ext>
+            </a:extLst>
+          </p:cNvPr>
+          <p:cNvSpPr/>
+          <p:nvPr/>
+        </p:nvSpPr>
+        <p:spPr>
+          <a:xfrm>
+            <a:off x="635000" y="4699000"/>
+            <a:ext cx="5270500" cy="1841500"/>
+          </a:xfrm>
+          <a:prstGeom prst="roundRect">
+            <a:avLst/>
+          </a:prstGeom>
+          <a:solidFill>
+            <a:srgbClr val="1A2639"/>
+          </a:solidFill>
+          <a:ln w="15240">
+            <a:solidFill>
+              <a:srgbClr val="2D3E50"/>
+            </a:solidFill>
+          </a:ln>
+        </p:spPr>
+        <p:style>
+          <a:lnRef idx="2">
+            <a:schemeClr val="accent1">
+              <a:shade val="15000"/>
+            </a:schemeClr>
+          </a:lnRef>
+          <a:fillRef idx="1">
+            <a:schemeClr val="accent1"/>
+          </a:fillRef>
+          <a:effectRef idx="0">
+            <a:schemeClr val="accent1"/>
+          </a:effectRef>
+          <a:fontRef idx="minor">
+            <a:schemeClr val="lt1"/>
+          </a:fontRef>
+        </p:style>
+        <p:txBody>
+          <a:bodyPr rtlCol="0" anchor="ctr"/>
+          <a:lstStyle/>
+          <a:p>
+            <a:pPr algn="ctr"/>
+            <a:endParaRPr lang="en-IN"/>
+          </a:p>
+        </p:txBody>
+      </p:sp>
+      <p:sp>
+        <p:nvSpPr>
+          <p:cNvPr id="9" name="TextBox 8">
+            <a:extLst>
+              <a:ext uri="{FF2B5EF4-FFF2-40B4-BE49-F238E27FC236}">
+                <a16:creationId xmlns:a16="http://schemas.microsoft.com/office/drawing/2014/main" id="{5455E08A-E682-E321-0EE8-04253790E34E}"/>
+              </a:ext>
+            </a:extLst>
+          </p:cNvPr>
+          <p:cNvSpPr txBox="1"/>
+          <p:nvPr/>
+        </p:nvSpPr>
+        <p:spPr>
+          <a:xfrm>
+            <a:off x="762000" y="4775200"/>
+            <a:ext cx="5016500" cy="284693"/>
+          </a:xfrm>
+          <a:prstGeom prst="rect">
+            <a:avLst/>
+          </a:prstGeom>
+          <a:noFill/>
+        </p:spPr>
+        <p:txBody>
+          <a:bodyPr vert="horz" rtlCol="0">
+            <a:spAutoFit/>
+          </a:bodyPr>
+          <a:lstStyle/>
+          <a:p>
+            <a:r>
+              <a:rPr lang="en-US" sz="1250" b="1">
+                <a:solidFill>
+                  <a:srgbClr val="F59E0B"/>
+                </a:solidFill>
+                <a:latin typeface="Segoe UI" panose="020B0502040204020203" pitchFamily="34" charset="0"/>
+              </a:rPr>
+              <a:t>1. Directed Graph Microgrid Map &amp; Controls</a:t>
+            </a:r>
+            <a:endParaRPr lang="en-IN" sz="1250" b="1">
+              <a:solidFill>
+                <a:srgbClr val="F59E0B"/>
+              </a:solidFill>
+              <a:latin typeface="Segoe UI" panose="020B0502040204020203" pitchFamily="34" charset="0"/>
+            </a:endParaRPr>
+          </a:p>
+        </p:txBody>
+      </p:sp>
+      <p:sp>
+        <p:nvSpPr>
+          <p:cNvPr id="10" name="TextBox 9">
+            <a:extLst>
+              <a:ext uri="{FF2B5EF4-FFF2-40B4-BE49-F238E27FC236}">
+                <a16:creationId xmlns:a16="http://schemas.microsoft.com/office/drawing/2014/main" id="{7BBD1081-CCF1-74ED-484A-2D54D13D3141}"/>
+              </a:ext>
+            </a:extLst>
+          </p:cNvPr>
+          <p:cNvSpPr txBox="1"/>
+          <p:nvPr/>
+        </p:nvSpPr>
+        <p:spPr>
+          <a:xfrm>
+            <a:off x="762000" y="5080000"/>
+            <a:ext cx="5016500" cy="738664"/>
+          </a:xfrm>
+          <a:prstGeom prst="rect">
+            <a:avLst/>
+          </a:prstGeom>
+          <a:noFill/>
+        </p:spPr>
+        <p:txBody>
+          <a:bodyPr vert="horz" wrap="square" rtlCol="0">
+            <a:spAutoFit/>
+          </a:bodyPr>
+          <a:lstStyle/>
+          <a:p>
+            <a:r>
+              <a:rPr lang="en-US" sz="1050">
+                <a:solidFill>
+                  <a:srgbClr val="94A3B8"/>
+                </a:solidFill>
+                <a:latin typeface="Segoe UI" panose="020B0502040204020203" pitchFamily="34" charset="0"/>
+              </a:rPr>
+              <a:t>•  Real-time Plotly digraph of Nerul Palm Beach (10 households).
+•  Gold = Solar Exporters (surplus &gt; 0); Green = Connected Consumers.
+•  Solid Green = Two-way lines; Dashed Orange = One-way feeders.
+•  Live KPIs: 100% Reachability, 30.2 kW Surplus, 1 SCC Community.</a:t>
+            </a:r>
+            <a:endParaRPr lang="en-IN" sz="1050">
+              <a:solidFill>
+                <a:srgbClr val="94A3B8"/>
+              </a:solidFill>
+              <a:latin typeface="Segoe UI" panose="020B0502040204020203" pitchFamily="34" charset="0"/>
+            </a:endParaRPr>
+          </a:p>
+        </p:txBody>
+      </p:sp>
+      <p:pic>
+        <p:nvPicPr>
+          <p:cNvPr id="12" name="Picture 11">
+            <a:extLst>
+              <a:ext uri="{FF2B5EF4-FFF2-40B4-BE49-F238E27FC236}">
+                <a16:creationId xmlns:a16="http://schemas.microsoft.com/office/drawing/2014/main" id="{D6E846F6-9AD2-1EAD-138D-86AB3910B538}"/>
+              </a:ext>
+            </a:extLst>
+          </p:cNvPr>
+          <p:cNvPicPr>
+            <a:picLocks/>
+          </p:cNvPicPr>
+          <p:nvPr/>
+        </p:nvPicPr>
+        <p:blipFill>
+          <a:blip r:embed="rId3">
+            <a:extLst>
+              <a:ext uri="{28A0092B-C50C-407E-A947-70E740481C1C}">
+                <a14:useLocalDpi xmlns:a14="http://schemas.microsoft.com/office/drawing/2010/main" val="0"/>
+              </a:ext>
+            </a:extLst>
+          </a:blip>
+          <a:stretch>
+            <a:fillRect/>
+          </a:stretch>
+        </p:blipFill>
+        <p:spPr>
+          <a:xfrm>
+            <a:off x="6286500" y="1206500"/>
+            <a:ext cx="5270500" cy="3365500"/>
+          </a:xfrm>
+          <a:prstGeom prst="rect">
+            <a:avLst/>
+          </a:prstGeom>
+          <a:ln w="19050">
+            <a:solidFill>
+              <a:schemeClr val="tx1"/>
+            </a:solidFill>
+          </a:ln>
+        </p:spPr>
+      </p:pic>
+      <p:sp>
+        <p:nvSpPr>
+          <p:cNvPr id="13" name="Rectangle: Rounded Corners 12">
+            <a:extLst>
+              <a:ext uri="{FF2B5EF4-FFF2-40B4-BE49-F238E27FC236}">
+                <a16:creationId xmlns:a16="http://schemas.microsoft.com/office/drawing/2014/main" id="{420CE860-8082-3468-A609-2EDD0C99D428}"/>
+              </a:ext>
+            </a:extLst>
+          </p:cNvPr>
+          <p:cNvSpPr/>
+          <p:nvPr/>
+        </p:nvSpPr>
+        <p:spPr>
+          <a:xfrm>
+            <a:off x="6286500" y="4699000"/>
+            <a:ext cx="5270500" cy="1841500"/>
+          </a:xfrm>
+          <a:prstGeom prst="roundRect">
+            <a:avLst/>
+          </a:prstGeom>
+          <a:solidFill>
+            <a:srgbClr val="1A2639"/>
+          </a:solidFill>
+          <a:ln w="15240">
+            <a:solidFill>
+              <a:srgbClr val="2D3E50"/>
+            </a:solidFill>
+          </a:ln>
+        </p:spPr>
+        <p:style>
+          <a:lnRef idx="2">
+            <a:schemeClr val="accent1">
+              <a:shade val="15000"/>
+            </a:schemeClr>
+          </a:lnRef>
+          <a:fillRef idx="1">
+            <a:schemeClr val="accent1"/>
+          </a:fillRef>
+          <a:effectRef idx="0">
+            <a:schemeClr val="accent1"/>
+          </a:effectRef>
+          <a:fontRef idx="minor">
+            <a:schemeClr val="lt1"/>
+          </a:fontRef>
+        </p:style>
+        <p:txBody>
+          <a:bodyPr rtlCol="0" anchor="ctr"/>
+          <a:lstStyle/>
+          <a:p>
+            <a:pPr algn="ctr"/>
+            <a:endParaRPr lang="en-IN"/>
+          </a:p>
+        </p:txBody>
+      </p:sp>
+      <p:sp>
+        <p:nvSpPr>
+          <p:cNvPr id="14" name="TextBox 13">
+            <a:extLst>
+              <a:ext uri="{FF2B5EF4-FFF2-40B4-BE49-F238E27FC236}">
+                <a16:creationId xmlns:a16="http://schemas.microsoft.com/office/drawing/2014/main" id="{2286B3B1-CE4E-B49A-F905-B8F1D23B7A13}"/>
+              </a:ext>
+            </a:extLst>
+          </p:cNvPr>
+          <p:cNvSpPr txBox="1"/>
+          <p:nvPr/>
+        </p:nvSpPr>
+        <p:spPr>
+          <a:xfrm>
+            <a:off x="6413500" y="4775200"/>
+            <a:ext cx="5016500" cy="284693"/>
+          </a:xfrm>
+          <a:prstGeom prst="rect">
+            <a:avLst/>
+          </a:prstGeom>
+          <a:noFill/>
+        </p:spPr>
+        <p:txBody>
+          <a:bodyPr vert="horz" rtlCol="0">
+            <a:spAutoFit/>
+          </a:bodyPr>
+          <a:lstStyle/>
+          <a:p>
+            <a:r>
+              <a:rPr lang="en-US" sz="1250" b="1">
+                <a:solidFill>
+                  <a:srgbClr val="38BDF8"/>
+                </a:solidFill>
+                <a:latin typeface="Segoe UI" panose="020B0502040204020203" pitchFamily="34" charset="0"/>
+              </a:rPr>
+              <a:t>2. Warshall Transitive Closure Matrix (R+)</a:t>
+            </a:r>
+            <a:endParaRPr lang="en-IN" sz="1250" b="1">
+              <a:solidFill>
+                <a:srgbClr val="38BDF8"/>
+              </a:solidFill>
+              <a:latin typeface="Segoe UI" panose="020B0502040204020203" pitchFamily="34" charset="0"/>
+            </a:endParaRPr>
+          </a:p>
+        </p:txBody>
+      </p:sp>
+      <p:sp>
+        <p:nvSpPr>
+          <p:cNvPr id="15" name="TextBox 14">
+            <a:extLst>
+              <a:ext uri="{FF2B5EF4-FFF2-40B4-BE49-F238E27FC236}">
+                <a16:creationId xmlns:a16="http://schemas.microsoft.com/office/drawing/2014/main" id="{D116209A-8E36-6DFA-6DED-220C46641018}"/>
+              </a:ext>
+            </a:extLst>
+          </p:cNvPr>
+          <p:cNvSpPr txBox="1"/>
+          <p:nvPr/>
+        </p:nvSpPr>
+        <p:spPr>
+          <a:xfrm>
+            <a:off x="6413500" y="5080000"/>
+            <a:ext cx="5016500" cy="738664"/>
+          </a:xfrm>
+          <a:prstGeom prst="rect">
+            <a:avLst/>
+          </a:prstGeom>
+          <a:noFill/>
+        </p:spPr>
+        <p:txBody>
+          <a:bodyPr vert="horz" wrap="square" rtlCol="0">
+            <a:spAutoFit/>
+          </a:bodyPr>
+          <a:lstStyle/>
+          <a:p>
+            <a:r>
+              <a:rPr lang="en-IN" sz="1050">
+                <a:solidFill>
+                  <a:srgbClr val="94A3B8"/>
+                </a:solidFill>
+                <a:latin typeface="Segoe UI" panose="020B0502040204020203" pitchFamily="34" charset="0"/>
+              </a:rPr>
+              <a:t>•  Custom O(V^3) Warshall algorithm computed step-by-step from scratch.
+•  Blue heatmap shows full multi-hop reachability: (i, j) = 1.
+•  Unlocks 74 multi-hop indirect power pathways beyond direct physical lines.
+•  Sidebar toggle switches instantly between direct lines (A) and (R^+).</a:t>
+            </a:r>
+          </a:p>
+        </p:txBody>
+      </p:sp>
+    </p:spTree>
+    <p:extLst>
+      <p:ext uri="{BB962C8B-B14F-4D97-AF65-F5344CB8AC3E}">
+        <p14:creationId xmlns:p14="http://schemas.microsoft.com/office/powerpoint/2010/main" val="2460096911"/>
+      </p:ext>
+    </p:extLst>
+  </p:cSld>
+  <p:clrMapOvr>
+    <a:masterClrMapping/>
+  </p:clrMapOvr>
+</p:sld>
+</file>
+
+<file path=ppt/slides/slide5.xml><?xml version="1.0" encoding="utf-8"?>
+<p:sld xmlns:a="http://schemas.openxmlformats.org/drawingml/2006/main" xmlns:r="http://schemas.openxmlformats.org/officeDocument/2006/relationships" xmlns:p="http://schemas.openxmlformats.org/presentationml/2006/main">
+  <p:cSld>
+    <p:spTree>
+      <p:nvGrpSpPr>
+        <p:cNvPr id="1" name=""/>
+        <p:cNvGrpSpPr/>
+        <p:nvPr/>
+      </p:nvGrpSpPr>
+      <p:grpSpPr>
+        <a:xfrm>
+          <a:off x="0" y="0"/>
+          <a:ext cx="0" cy="0"/>
+          <a:chOff x="0" y="0"/>
+          <a:chExt cx="0" cy="0"/>
+        </a:xfrm>
+      </p:grpSpPr>
+      <p:sp>
+        <p:nvSpPr>
+          <p:cNvPr id="2" name="Rectangle 1">
+            <a:extLst>
+              <a:ext uri="{FF2B5EF4-FFF2-40B4-BE49-F238E27FC236}">
+                <a16:creationId xmlns:a16="http://schemas.microsoft.com/office/drawing/2014/main" id="{08EAE6D5-9FAA-5757-3016-39DED821AE2D}"/>
+              </a:ext>
+            </a:extLst>
+          </p:cNvPr>
+          <p:cNvSpPr/>
+          <p:nvPr/>
+        </p:nvSpPr>
+        <p:spPr>
+          <a:xfrm>
+            <a:off x="0" y="0"/>
+            <a:ext cx="12192000" cy="6858000"/>
+          </a:xfrm>
+          <a:prstGeom prst="rect">
+            <a:avLst/>
+          </a:prstGeom>
+          <a:solidFill>
+            <a:srgbClr val="0B1120"/>
+          </a:solidFill>
+          <a:ln w="12700" cap="flat" cmpd="sng" algn="ctr">
+            <a:noFill/>
+            <a:prstDash val="solid"/>
+            <a:miter lim="800000"/>
+          </a:ln>
+          <a:effectLst/>
+          <a:extLst>
+            <a:ext uri="{91240B29-F687-4F45-9708-019B960494DF}">
+              <a14:hiddenLine xmlns:a14="http://schemas.microsoft.com/office/drawing/2010/main" w="12700" cap="flat" cmpd="sng" algn="ctr">
+                <a:solidFill>
+                  <a:schemeClr val="accent1">
+                    <a:shade val="15000"/>
+                  </a:schemeClr>
+                </a:solidFill>
+                <a:prstDash val="solid"/>
+                <a:miter lim="800000"/>
+              </a14:hiddenLine>
+            </a:ext>
+          </a:extLst>
+        </p:spPr>
+        <p:style>
+          <a:lnRef idx="2">
+            <a:schemeClr val="accent1">
+              <a:shade val="15000"/>
+            </a:schemeClr>
+          </a:lnRef>
+          <a:fillRef idx="1">
+            <a:schemeClr val="accent1"/>
+          </a:fillRef>
+          <a:effectRef idx="0">
+            <a:schemeClr val="accent1"/>
+          </a:effectRef>
+          <a:fontRef idx="minor">
+            <a:schemeClr val="lt1"/>
+          </a:fontRef>
+        </p:style>
+        <p:txBody>
+          <a:bodyPr rtlCol="0" anchor="ctr"/>
+          <a:lstStyle/>
+          <a:p>
+            <a:pPr algn="ctr"/>
+            <a:endParaRPr lang="en-IN"/>
+          </a:p>
+        </p:txBody>
+      </p:sp>
+      <p:sp>
+        <p:nvSpPr>
+          <p:cNvPr id="3" name="Rectangle 2">
+            <a:extLst>
+              <a:ext uri="{FF2B5EF4-FFF2-40B4-BE49-F238E27FC236}">
+                <a16:creationId xmlns:a16="http://schemas.microsoft.com/office/drawing/2014/main" id="{BBDD8C43-C41E-E80C-6A1A-053D76F69B47}"/>
+              </a:ext>
+            </a:extLst>
+          </p:cNvPr>
+          <p:cNvSpPr/>
+          <p:nvPr/>
+        </p:nvSpPr>
+        <p:spPr>
+          <a:xfrm>
+            <a:off x="0" y="0"/>
+            <a:ext cx="12192000" cy="76200"/>
+          </a:xfrm>
+          <a:prstGeom prst="rect">
+            <a:avLst/>
+          </a:prstGeom>
+          <a:solidFill>
+            <a:srgbClr val="10B981"/>
+          </a:solidFill>
+          <a:ln w="12700" cap="flat" cmpd="sng" algn="ctr">
+            <a:noFill/>
+            <a:prstDash val="solid"/>
+            <a:miter lim="800000"/>
+          </a:ln>
+          <a:effectLst/>
+          <a:extLst>
+            <a:ext uri="{91240B29-F687-4F45-9708-019B960494DF}">
+              <a14:hiddenLine xmlns:a14="http://schemas.microsoft.com/office/drawing/2010/main" w="12700" cap="flat" cmpd="sng" algn="ctr">
+                <a:solidFill>
+                  <a:schemeClr val="accent1">
+                    <a:shade val="15000"/>
+                  </a:schemeClr>
+                </a:solidFill>
+                <a:prstDash val="solid"/>
+                <a:miter lim="800000"/>
+              </a14:hiddenLine>
+            </a:ext>
+          </a:extLst>
+        </p:spPr>
+        <p:style>
+          <a:lnRef idx="2">
+            <a:schemeClr val="accent1">
+              <a:shade val="15000"/>
+            </a:schemeClr>
+          </a:lnRef>
+          <a:fillRef idx="1">
+            <a:schemeClr val="accent1"/>
+          </a:fillRef>
+          <a:effectRef idx="0">
+            <a:schemeClr val="accent1"/>
+          </a:effectRef>
+          <a:fontRef idx="minor">
+            <a:schemeClr val="lt1"/>
+          </a:fontRef>
+        </p:style>
+        <p:txBody>
+          <a:bodyPr rtlCol="0" anchor="ctr"/>
+          <a:lstStyle/>
+          <a:p>
+            <a:pPr algn="ctr"/>
+            <a:endParaRPr lang="en-IN"/>
+          </a:p>
+        </p:txBody>
+      </p:sp>
+      <p:sp>
+        <p:nvSpPr>
+          <p:cNvPr id="4" name="Rectangle: Rounded Corners 3">
+            <a:extLst>
+              <a:ext uri="{FF2B5EF4-FFF2-40B4-BE49-F238E27FC236}">
+                <a16:creationId xmlns:a16="http://schemas.microsoft.com/office/drawing/2014/main" id="{06D6A437-5FAA-B32C-0315-4DCC16C778E8}"/>
+              </a:ext>
+            </a:extLst>
+          </p:cNvPr>
+          <p:cNvSpPr/>
+          <p:nvPr/>
+        </p:nvSpPr>
+        <p:spPr>
+          <a:xfrm>
+            <a:off x="635000" y="279400"/>
+            <a:ext cx="3556000" cy="330200"/>
+          </a:xfrm>
+          <a:prstGeom prst="roundRect">
+            <a:avLst/>
+          </a:prstGeom>
+          <a:solidFill>
+            <a:srgbClr val="1A2639"/>
+          </a:solidFill>
+          <a:ln w="15240">
+            <a:solidFill>
+              <a:srgbClr val="10B981"/>
+            </a:solidFill>
+          </a:ln>
+        </p:spPr>
+        <p:style>
+          <a:lnRef idx="2">
+            <a:schemeClr val="accent1">
+              <a:shade val="15000"/>
+            </a:schemeClr>
+          </a:lnRef>
+          <a:fillRef idx="1">
+            <a:schemeClr val="accent1"/>
+          </a:fillRef>
+          <a:effectRef idx="0">
+            <a:schemeClr val="accent1"/>
+          </a:effectRef>
+          <a:fontRef idx="minor">
+            <a:schemeClr val="lt1"/>
+          </a:fontRef>
+        </p:style>
+        <p:txBody>
+          <a:bodyPr rtlCol="0" anchor="ctr"/>
+          <a:lstStyle/>
+          <a:p>
+            <a:pPr algn="ctr"/>
+            <a:r>
+              <a:rPr lang="en-IN" sz="1000" b="1">
+                <a:solidFill>
+                  <a:srgbClr val="10B981"/>
+                </a:solidFill>
+                <a:latin typeface="Segoe UI" panose="020B0502040204020203" pitchFamily="34" charset="0"/>
+              </a:rPr>
+              <a:t>LIVE DEMO • OPTIMIZATION &amp; SETTLEMENT</a:t>
+            </a:r>
+          </a:p>
+        </p:txBody>
+      </p:sp>
+      <p:sp>
+        <p:nvSpPr>
+          <p:cNvPr id="5" name="TextBox 4">
+            <a:extLst>
+              <a:ext uri="{FF2B5EF4-FFF2-40B4-BE49-F238E27FC236}">
+                <a16:creationId xmlns:a16="http://schemas.microsoft.com/office/drawing/2014/main" id="{CFA78B02-F49B-4268-D096-71D783890D05}"/>
+              </a:ext>
+            </a:extLst>
+          </p:cNvPr>
+          <p:cNvSpPr txBox="1"/>
+          <p:nvPr/>
+        </p:nvSpPr>
+        <p:spPr>
+          <a:xfrm>
+            <a:off x="635000" y="635000"/>
+            <a:ext cx="10922000" cy="446276"/>
+          </a:xfrm>
+          <a:prstGeom prst="rect">
+            <a:avLst/>
+          </a:prstGeom>
+          <a:noFill/>
+        </p:spPr>
+        <p:txBody>
+          <a:bodyPr vert="horz" rtlCol="0">
+            <a:spAutoFit/>
+          </a:bodyPr>
+          <a:lstStyle/>
+          <a:p>
+            <a:r>
+              <a:rPr lang="en-US" sz="2300" b="1">
+                <a:solidFill>
+                  <a:srgbClr val="FFFFFF"/>
+                </a:solidFill>
+                <a:latin typeface="Segoe UI" panose="020B0502040204020203" pitchFamily="34" charset="0"/>
+              </a:rPr>
+              <a:t>Graph AI Missing Link Optimizer &amp; P2P Energy Trading (Rs)</a:t>
+            </a:r>
+            <a:endParaRPr lang="en-IN" sz="2300" b="1">
+              <a:solidFill>
+                <a:srgbClr val="FFFFFF"/>
+              </a:solidFill>
+              <a:latin typeface="Segoe UI" panose="020B0502040204020203" pitchFamily="34" charset="0"/>
+            </a:endParaRPr>
+          </a:p>
+        </p:txBody>
+      </p:sp>
+      <p:pic>
+        <p:nvPicPr>
+          <p:cNvPr id="7" name="Picture 6">
+            <a:extLst>
+              <a:ext uri="{FF2B5EF4-FFF2-40B4-BE49-F238E27FC236}">
+                <a16:creationId xmlns:a16="http://schemas.microsoft.com/office/drawing/2014/main" id="{7E3BA625-A21A-0FD1-6814-791592D9D4DA}"/>
+              </a:ext>
+            </a:extLst>
+          </p:cNvPr>
+          <p:cNvPicPr>
+            <a:picLocks/>
+          </p:cNvPicPr>
+          <p:nvPr/>
+        </p:nvPicPr>
+        <p:blipFill>
+          <a:blip r:embed="rId2">
+            <a:extLst>
+              <a:ext uri="{28A0092B-C50C-407E-A947-70E740481C1C}">
+                <a14:useLocalDpi xmlns:a14="http://schemas.microsoft.com/office/drawing/2010/main" val="0"/>
+              </a:ext>
+            </a:extLst>
+          </a:blip>
+          <a:stretch>
+            <a:fillRect/>
+          </a:stretch>
+        </p:blipFill>
+        <p:spPr>
+          <a:xfrm>
+            <a:off x="635000" y="1206500"/>
+            <a:ext cx="5270500" cy="3365500"/>
+          </a:xfrm>
+          <a:prstGeom prst="rect">
+            <a:avLst/>
+          </a:prstGeom>
+          <a:ln w="19050">
+            <a:solidFill>
+              <a:schemeClr val="tx1"/>
+            </a:solidFill>
+          </a:ln>
+        </p:spPr>
+      </p:pic>
+      <p:sp>
+        <p:nvSpPr>
+          <p:cNvPr id="8" name="Rectangle: Rounded Corners 7">
+            <a:extLst>
+              <a:ext uri="{FF2B5EF4-FFF2-40B4-BE49-F238E27FC236}">
+                <a16:creationId xmlns:a16="http://schemas.microsoft.com/office/drawing/2014/main" id="{CB394FDE-DE64-68DD-C339-45591A0F6D33}"/>
+              </a:ext>
+            </a:extLst>
+          </p:cNvPr>
+          <p:cNvSpPr/>
+          <p:nvPr/>
+        </p:nvSpPr>
+        <p:spPr>
+          <a:xfrm>
+            <a:off x="635000" y="4699000"/>
+            <a:ext cx="5270500" cy="1841500"/>
+          </a:xfrm>
+          <a:prstGeom prst="roundRect">
+            <a:avLst/>
+          </a:prstGeom>
+          <a:solidFill>
+            <a:srgbClr val="1A2639"/>
+          </a:solidFill>
+          <a:ln w="15240">
+            <a:solidFill>
+              <a:srgbClr val="2D3E50"/>
+            </a:solidFill>
+          </a:ln>
+        </p:spPr>
+        <p:style>
+          <a:lnRef idx="2">
+            <a:schemeClr val="accent1">
+              <a:shade val="15000"/>
+            </a:schemeClr>
+          </a:lnRef>
+          <a:fillRef idx="1">
+            <a:schemeClr val="accent1"/>
+          </a:fillRef>
+          <a:effectRef idx="0">
+            <a:schemeClr val="accent1"/>
+          </a:effectRef>
+          <a:fontRef idx="minor">
+            <a:schemeClr val="lt1"/>
+          </a:fontRef>
+        </p:style>
+        <p:txBody>
+          <a:bodyPr rtlCol="0" anchor="ctr"/>
+          <a:lstStyle/>
+          <a:p>
+            <a:pPr algn="ctr"/>
+            <a:endParaRPr lang="en-IN"/>
+          </a:p>
+        </p:txBody>
+      </p:sp>
+      <p:sp>
+        <p:nvSpPr>
+          <p:cNvPr id="9" name="TextBox 8">
+            <a:extLst>
+              <a:ext uri="{FF2B5EF4-FFF2-40B4-BE49-F238E27FC236}">
+                <a16:creationId xmlns:a16="http://schemas.microsoft.com/office/drawing/2014/main" id="{BE836718-0898-9087-2AF3-00E88CB8C12D}"/>
+              </a:ext>
+            </a:extLst>
+          </p:cNvPr>
+          <p:cNvSpPr txBox="1"/>
+          <p:nvPr/>
+        </p:nvSpPr>
+        <p:spPr>
+          <a:xfrm>
+            <a:off x="762000" y="4775200"/>
+            <a:ext cx="5016500" cy="284693"/>
+          </a:xfrm>
+          <a:prstGeom prst="rect">
+            <a:avLst/>
+          </a:prstGeom>
+          <a:noFill/>
+        </p:spPr>
+        <p:txBody>
+          <a:bodyPr vert="horz" rtlCol="0">
+            <a:spAutoFit/>
+          </a:bodyPr>
+          <a:lstStyle/>
+          <a:p>
+            <a:r>
+              <a:rPr lang="en-US" sz="1250" b="1">
+                <a:solidFill>
+                  <a:srgbClr val="F59E0B"/>
+                </a:solidFill>
+                <a:latin typeface="Segoe UI" panose="020B0502040204020203" pitchFamily="34" charset="0"/>
+              </a:rPr>
+              <a:t>3. Graph AI Missing Line Optimizer</a:t>
+            </a:r>
+            <a:endParaRPr lang="en-IN" sz="1250" b="1">
+              <a:solidFill>
+                <a:srgbClr val="F59E0B"/>
+              </a:solidFill>
+              <a:latin typeface="Segoe UI" panose="020B0502040204020203" pitchFamily="34" charset="0"/>
+            </a:endParaRPr>
+          </a:p>
+        </p:txBody>
+      </p:sp>
+      <p:sp>
+        <p:nvSpPr>
+          <p:cNvPr id="10" name="TextBox 9">
+            <a:extLst>
+              <a:ext uri="{FF2B5EF4-FFF2-40B4-BE49-F238E27FC236}">
+                <a16:creationId xmlns:a16="http://schemas.microsoft.com/office/drawing/2014/main" id="{9BFD0025-09AA-9281-9B6A-BF416F2F810F}"/>
+              </a:ext>
+            </a:extLst>
+          </p:cNvPr>
+          <p:cNvSpPr txBox="1"/>
+          <p:nvPr/>
+        </p:nvSpPr>
+        <p:spPr>
+          <a:xfrm>
+            <a:off x="762000" y="5080000"/>
+            <a:ext cx="5016500" cy="738664"/>
+          </a:xfrm>
+          <a:prstGeom prst="rect">
+            <a:avLst/>
+          </a:prstGeom>
+          <a:noFill/>
+        </p:spPr>
+        <p:txBody>
+          <a:bodyPr vert="horz" wrap="square" rtlCol="0">
+            <a:spAutoFit/>
+          </a:bodyPr>
+          <a:lstStyle/>
+          <a:p>
+            <a:r>
+              <a:rPr lang="en-US" sz="1050">
+                <a:solidFill>
+                  <a:srgbClr val="94A3B8"/>
+                </a:solidFill>
+                <a:latin typeface="Segoe UI" panose="020B0502040204020203" pitchFamily="34" charset="0"/>
+              </a:rPr>
+              <a:t>•  Scans all candidate missing directed lines (u, v) not yet in the grid.
+•  Score = (Delta Powered Homes x Delta kW Demand Served) / Cable Distance.
+•  Recommends optimal line addition with real-time before/after diff graph.
+•  'Wire Selected Link' button adds the cable live in animated cyan.</a:t>
+            </a:r>
+            <a:endParaRPr lang="en-IN" sz="1050">
+              <a:solidFill>
+                <a:srgbClr val="94A3B8"/>
+              </a:solidFill>
+              <a:latin typeface="Segoe UI" panose="020B0502040204020203" pitchFamily="34" charset="0"/>
+            </a:endParaRPr>
+          </a:p>
+        </p:txBody>
+      </p:sp>
+      <p:pic>
+        <p:nvPicPr>
+          <p:cNvPr id="12" name="Picture 11">
+            <a:extLst>
+              <a:ext uri="{FF2B5EF4-FFF2-40B4-BE49-F238E27FC236}">
+                <a16:creationId xmlns:a16="http://schemas.microsoft.com/office/drawing/2014/main" id="{8483D159-76F4-6189-8E9B-E592B3A30B94}"/>
+              </a:ext>
+            </a:extLst>
+          </p:cNvPr>
+          <p:cNvPicPr>
+            <a:picLocks/>
+          </p:cNvPicPr>
+          <p:nvPr/>
+        </p:nvPicPr>
+        <p:blipFill>
+          <a:blip r:embed="rId3">
+            <a:extLst>
+              <a:ext uri="{28A0092B-C50C-407E-A947-70E740481C1C}">
+                <a14:useLocalDpi xmlns:a14="http://schemas.microsoft.com/office/drawing/2010/main" val="0"/>
+              </a:ext>
+            </a:extLst>
+          </a:blip>
+          <a:stretch>
+            <a:fillRect/>
+          </a:stretch>
+        </p:blipFill>
+        <p:spPr>
+          <a:xfrm>
+            <a:off x="6286500" y="1206500"/>
+            <a:ext cx="5270500" cy="3365500"/>
+          </a:xfrm>
+          <a:prstGeom prst="rect">
+            <a:avLst/>
+          </a:prstGeom>
+          <a:ln w="19050">
+            <a:solidFill>
+              <a:schemeClr val="tx1"/>
+            </a:solidFill>
+          </a:ln>
+        </p:spPr>
+      </p:pic>
+      <p:sp>
+        <p:nvSpPr>
+          <p:cNvPr id="13" name="Rectangle: Rounded Corners 12">
+            <a:extLst>
+              <a:ext uri="{FF2B5EF4-FFF2-40B4-BE49-F238E27FC236}">
+                <a16:creationId xmlns:a16="http://schemas.microsoft.com/office/drawing/2014/main" id="{C621CF05-ED4F-4B39-D0A0-2729DEE77043}"/>
+              </a:ext>
+            </a:extLst>
+          </p:cNvPr>
+          <p:cNvSpPr/>
+          <p:nvPr/>
+        </p:nvSpPr>
+        <p:spPr>
+          <a:xfrm>
+            <a:off x="6286500" y="4699000"/>
+            <a:ext cx="5270500" cy="1841500"/>
+          </a:xfrm>
+          <a:prstGeom prst="roundRect">
+            <a:avLst/>
+          </a:prstGeom>
+          <a:solidFill>
+            <a:srgbClr val="1A2639"/>
+          </a:solidFill>
+          <a:ln w="15240">
+            <a:solidFill>
+              <a:srgbClr val="2D3E50"/>
+            </a:solidFill>
+          </a:ln>
+        </p:spPr>
+        <p:style>
+          <a:lnRef idx="2">
+            <a:schemeClr val="accent1">
+              <a:shade val="15000"/>
+            </a:schemeClr>
+          </a:lnRef>
+          <a:fillRef idx="1">
+            <a:schemeClr val="accent1"/>
+          </a:fillRef>
+          <a:effectRef idx="0">
+            <a:schemeClr val="accent1"/>
+          </a:effectRef>
+          <a:fontRef idx="minor">
+            <a:schemeClr val="lt1"/>
+          </a:fontRef>
+        </p:style>
+        <p:txBody>
+          <a:bodyPr rtlCol="0" anchor="ctr"/>
+          <a:lstStyle/>
+          <a:p>
+            <a:pPr algn="ctr"/>
+            <a:endParaRPr lang="en-IN"/>
+          </a:p>
+        </p:txBody>
+      </p:sp>
+      <p:sp>
+        <p:nvSpPr>
+          <p:cNvPr id="14" name="TextBox 13">
+            <a:extLst>
+              <a:ext uri="{FF2B5EF4-FFF2-40B4-BE49-F238E27FC236}">
+                <a16:creationId xmlns:a16="http://schemas.microsoft.com/office/drawing/2014/main" id="{59ABD969-91E7-051F-19D2-5A67FDD7D799}"/>
+              </a:ext>
+            </a:extLst>
+          </p:cNvPr>
+          <p:cNvSpPr txBox="1"/>
+          <p:nvPr/>
+        </p:nvSpPr>
+        <p:spPr>
+          <a:xfrm>
+            <a:off x="6413500" y="4775200"/>
+            <a:ext cx="5016500" cy="284693"/>
+          </a:xfrm>
+          <a:prstGeom prst="rect">
+            <a:avLst/>
+          </a:prstGeom>
+          <a:noFill/>
+        </p:spPr>
+        <p:txBody>
+          <a:bodyPr vert="horz" rtlCol="0">
+            <a:spAutoFit/>
+          </a:bodyPr>
+          <a:lstStyle/>
+          <a:p>
+            <a:r>
+              <a:rPr lang="en-US" sz="1250" b="1">
+                <a:solidFill>
+                  <a:srgbClr val="10B981"/>
+                </a:solidFill>
+                <a:latin typeface="Segoe UI" panose="020B0502040204020203" pitchFamily="34" charset="0"/>
+              </a:rPr>
+              <a:t>4. P2P Energy Trade Settlement (INR Rs)</a:t>
+            </a:r>
+            <a:endParaRPr lang="en-IN" sz="1250" b="1">
+              <a:solidFill>
+                <a:srgbClr val="10B981"/>
+              </a:solidFill>
+              <a:latin typeface="Segoe UI" panose="020B0502040204020203" pitchFamily="34" charset="0"/>
+            </a:endParaRPr>
+          </a:p>
+        </p:txBody>
+      </p:sp>
+      <p:sp>
+        <p:nvSpPr>
+          <p:cNvPr id="15" name="TextBox 14">
+            <a:extLst>
+              <a:ext uri="{FF2B5EF4-FFF2-40B4-BE49-F238E27FC236}">
+                <a16:creationId xmlns:a16="http://schemas.microsoft.com/office/drawing/2014/main" id="{80E91A3F-3054-D792-178C-F4A19B26EAF2}"/>
+              </a:ext>
+            </a:extLst>
+          </p:cNvPr>
+          <p:cNvSpPr txBox="1"/>
+          <p:nvPr/>
+        </p:nvSpPr>
+        <p:spPr>
+          <a:xfrm>
+            <a:off x="6413500" y="5080000"/>
+            <a:ext cx="5016500" cy="738664"/>
+          </a:xfrm>
+          <a:prstGeom prst="rect">
+            <a:avLst/>
+          </a:prstGeom>
+          <a:noFill/>
+        </p:spPr>
+        <p:txBody>
+          <a:bodyPr vert="horz" wrap="square" rtlCol="0">
+            <a:spAutoFit/>
+          </a:bodyPr>
+          <a:lstStyle/>
+          <a:p>
+            <a:r>
+              <a:rPr lang="en-IN" sz="1050">
+                <a:solidFill>
+                  <a:srgbClr val="94A3B8"/>
+                </a:solidFill>
+                <a:latin typeface="Segoe UI" panose="020B0502040204020203" pitchFamily="34" charset="0"/>
+              </a:rPr>
+              <a:t>•  Multi-hop line dissipation model: Delivered = Surplus x Product(1 - loss_i).
+•  Greedy shortest-distance matching pairs neighbors to minimize ohmic losses.
+•  Localized to Navi Mumbai tariffs (MSEDCL Rs 10/kWh vs P2P Rs 5/kWh).
+•  Generates Rs 148.03/hr in direct savings for the Nerul community!</a:t>
+            </a:r>
+          </a:p>
+        </p:txBody>
+      </p:sp>
+    </p:spTree>
+    <p:extLst>
+      <p:ext uri="{BB962C8B-B14F-4D97-AF65-F5344CB8AC3E}">
+        <p14:creationId xmlns:p14="http://schemas.microsoft.com/office/powerpoint/2010/main" val="2130156598"/>
       </p:ext>
     </p:extLst>
   </p:cSld>

</xml_diff>